<commit_message>
Fix invalid shape enum in deck generator
Two helpers in theme.js passed a raw integer (1) to slide.addShape() instead of
the pptxgenjs shape type string 'rect', producing malformed p:sp XML that
PowerPoint flagged on open with a Repair prompt.

Regenerated all seven Day 1 decks.

Co-authored-by: Copilot <223556219+Copilot@users.noreply.github.com>
</commit_message>
<xml_diff>
--- a/decks/day1/module-2-foundry-portal.pptx
+++ b/decks/day1/module-2-foundry-portal.pptx
@@ -4328,7 +4328,7 @@
             <a:off x="365760" y="4343400"/>
             <a:ext cx="8412480" cy="457200"/>
           </a:xfrm>
-          <a:prstGeom prst="1">
+          <a:prstGeom prst="rect">
             <a:avLst/>
           </a:prstGeom>
           <a:solidFill>
@@ -5084,7 +5084,7 @@
             <a:off x="365760" y="1417320"/>
             <a:ext cx="8412480" cy="548640"/>
           </a:xfrm>
-          <a:prstGeom prst="1">
+          <a:prstGeom prst="rect">
             <a:avLst/>
           </a:prstGeom>
           <a:solidFill>

</xml_diff>

<commit_message>
Day 1 Module 2: add Foundry resource architecture material
Per learn.microsoft.com/en-us/azure/foundry/concepts/architecture,
add the four-layer model: Foundry resource, project, project assets,
connected resources.

Changes:
- Replaced the thin generic 'Foundry hierarchy' slide with a diagrammatic
  'Foundry resource architecture' slide showing all four layers
- Added a 'What lives where + starter RBAC' slide right after
- Rewrote the Connections slide to reinforce that connected resources
  are separate governance boundaries
- Updated Common Gotchas: 401/403 = missing Foundry User (previously
  Azure AI User) at the Foundry resource scope, not the project
- Added a Foundry architecture section to docs/terminology.md
- Module 2 slide count 14 -> 15

Co-authored-by: Copilot <223556219+Copilot@users.noreply.github.com>
</commit_message>
<xml_diff>
--- a/decks/day1/module-2-foundry-portal.pptx
+++ b/decks/day1/module-2-foundry-portal.pptx
@@ -20,9 +20,10 @@
     <p:sldId id="268" r:id="rId14"/>
     <p:sldId id="269" r:id="rId15"/>
     <p:sldId id="270" r:id="rId16"/>
+    <p:sldId id="271" r:id="rId17"/>
   </p:sldIdLst>
   <p:notesMasterIdLst>
-    <p:notesMasterId r:id="rId17"/>
+    <p:notesMasterId r:id="rId18"/>
   </p:notesMasterIdLst>
   <p:sldSz cx="9144000" cy="5143500"/>
   <p:notesSz cx="5143500" cy="9144000"/>
@@ -604,7 +605,7 @@
           <a:p>
             <a:r>
               <a:rPr lang="en-US" dirty="0"/>
-              <a:t>Bookmark this. We use it lightly today and go deep Day 2. Note: Toolbox = MCP under the hood; ties into Day 3 nicely.</a:t>
+              <a:t>Transition to portal areas we introduce today and revisit later.</a:t>
             </a:r>
             <a:endParaRPr lang="en-US" dirty="0"/>
           </a:p>
@@ -692,7 +693,7 @@
           <a:p>
             <a:r>
               <a:rPr lang="en-US" dirty="0"/>
-              <a:t>This is Day 2's main course. Just plant the flag.</a:t>
+              <a:t>Bookmark this. We use it lightly today and go deep Day 2. Note: Toolbox = MCP under the hood; ties into Day 3 nicely.</a:t>
             </a:r>
             <a:endParaRPr lang="en-US" dirty="0"/>
           </a:p>
@@ -780,7 +781,7 @@
           <a:p>
             <a:r>
               <a:rPr lang="en-US" dirty="0"/>
-              <a:t>Actions vs. Knowledge is the compass for Days 2–3. Actions maps to Day 3 (MCP). Knowledge maps to Day 2 (Foundry IQ, RAG).</a:t>
+              <a:t>This is Day 2's main course. Just plant the flag.</a:t>
             </a:r>
             <a:endParaRPr lang="en-US" dirty="0"/>
           </a:p>
@@ -868,7 +869,7 @@
           <a:p>
             <a:r>
               <a:rPr lang="en-US" dirty="0"/>
-              <a:t>Give attendees the diagnostic sequence: quota → RBAC → region. In that order.</a:t>
+              <a:t>Actions vs. Knowledge is the compass for Days 2–3. Actions maps to Day 3 (MCP). Knowledge maps to Day 2 (Foundry IQ, RAG).</a:t>
             </a:r>
             <a:endParaRPr lang="en-US" dirty="0"/>
           </a:p>
@@ -956,7 +957,7 @@
           <a:p>
             <a:r>
               <a:rPr lang="en-US" dirty="0"/>
-              <a:t>Screen share your portal. Move steadily. Ask attendees to raise a hand if they can't complete steps 1–4 during the demo.</a:t>
+              <a:t>Give attendees the diagnostic sequence: quota → RBAC → region. In that order.</a:t>
             </a:r>
             <a:endParaRPr lang="en-US" dirty="0"/>
           </a:p>
@@ -1044,7 +1045,7 @@
           <a:p>
             <a:r>
               <a:rPr lang="en-US" dirty="0"/>
-              <a:t>Short recap. Confirm everyone has their project endpoint copied.</a:t>
+              <a:t>Screen share your portal. Move steadily. Ask attendees to raise a hand if they can't complete steps 1–4 during the demo.</a:t>
             </a:r>
             <a:endParaRPr lang="en-US" dirty="0"/>
           </a:p>
@@ -1068,6 +1069,94 @@
             <a:fld id="{F7021451-1387-4CA6-816F-3879F97B5CBC}" type="slidenum">
               <a:rPr lang="en-US"/>
               <a:t>15</a:t>
+            </a:fld>
+            <a:endParaRPr lang="en-US"/>
+          </a:p>
+        </p:txBody>
+      </p:sp>
+    </p:spTree>
+    <p:extLst>
+      <p:ext uri="{BB962C8B-B14F-4D97-AF65-F5344CB8AC3E}">
+        <p14:creationId xmlns:p14="http://schemas.microsoft.com/office/powerpoint/2010/main" val="1024086991"/>
+      </p:ext>
+    </p:extLst>
+  </p:cSld>
+  <p:clrMapOvr>
+    <a:masterClrMapping/>
+  </p:clrMapOvr>
+</p:notes>
+</file>
+
+<file path=ppt/notesSlides/notesSlide16.xml><?xml version="1.0" encoding="utf-8"?>
+<p:notes xmlns:a="http://schemas.openxmlformats.org/drawingml/2006/main" xmlns:r="http://schemas.openxmlformats.org/officeDocument/2006/relationships" xmlns:p="http://schemas.openxmlformats.org/presentationml/2006/main">
+  <p:cSld>
+    <p:spTree>
+      <p:nvGrpSpPr>
+        <p:cNvPr id="1" name=""/>
+        <p:cNvGrpSpPr/>
+        <p:nvPr/>
+      </p:nvGrpSpPr>
+      <p:grpSpPr>
+        <a:xfrm>
+          <a:off x="0" y="0"/>
+          <a:ext cx="0" cy="0"/>
+          <a:chOff x="0" y="0"/>
+          <a:chExt cx="0" cy="0"/>
+        </a:xfrm>
+      </p:grpSpPr>
+      <p:sp>
+        <p:nvSpPr>
+          <p:cNvPr id="2" name="Slide Image Placeholder 1"/>
+          <p:cNvSpPr>
+            <a:spLocks noGrp="1" noRot="1" noChangeAspect="1"/>
+          </p:cNvSpPr>
+          <p:nvPr>
+            <p:ph type="sldImg"/>
+          </p:nvPr>
+        </p:nvSpPr>
+        <p:spPr/>
+      </p:sp>
+      <p:sp>
+        <p:nvSpPr>
+          <p:cNvPr id="3" name="Notes Placeholder 2"/>
+          <p:cNvSpPr>
+            <a:spLocks noGrp="1"/>
+          </p:cNvSpPr>
+          <p:nvPr>
+            <p:ph type="body" idx="1"/>
+          </p:nvPr>
+        </p:nvSpPr>
+        <p:spPr/>
+        <p:txBody>
+          <a:bodyPr/>
+          <a:lstStyle/>
+          <a:p>
+            <a:r>
+              <a:rPr lang="en-US" dirty="0"/>
+              <a:t>Short recap. Confirm everyone has their project endpoint copied.</a:t>
+            </a:r>
+            <a:endParaRPr lang="en-US" dirty="0"/>
+          </a:p>
+        </p:txBody>
+      </p:sp>
+      <p:sp>
+        <p:nvSpPr>
+          <p:cNvPr id="4" name="Slide Number Placeholder 3"/>
+          <p:cNvSpPr>
+            <a:spLocks noGrp="1"/>
+          </p:cNvSpPr>
+          <p:nvPr>
+            <p:ph type="sldNum" sz="quarter" idx="10"/>
+          </p:nvPr>
+        </p:nvSpPr>
+        <p:spPr/>
+        <p:txBody>
+          <a:bodyPr/>
+          <a:lstStyle/>
+          <a:p>
+            <a:fld id="{F7021451-1387-4CA6-816F-3879F97B5CBC}" type="slidenum">
+              <a:rPr lang="en-US"/>
+              <a:t>16</a:t>
             </a:fld>
             <a:endParaRPr lang="en-US"/>
           </a:p>
@@ -1220,7 +1309,7 @@
           <a:p>
             <a:r>
               <a:rPr lang="en-US" dirty="0"/>
-              <a:t>Emphasize: you always operate inside a project. If in doubt, 'what project are we in?'</a:t>
+              <a:t>This is the mental map for Foundry governance. Emphasize that connected resources (Storage, Key Vault, AI Search) are independent Azure resources — you manage their networking and access separately. The Foundry resource references them through connections.</a:t>
             </a:r>
             <a:endParaRPr lang="en-US" dirty="0"/>
           </a:p>
@@ -1308,7 +1397,7 @@
           <a:p>
             <a:r>
               <a:rPr lang="en-US" dirty="0"/>
-              <a:t>Show them where to grab this from the portal. Overview page → 'Endpoints and keys' or similar (verify current wording live).</a:t>
+              <a:t>Foundry User role was previously called Azure AI User — attendees may see either name during the rollout. RBAC scopes at both resource and project level; 401/403 in the lab almost always means missing Foundry User at the resource scope.</a:t>
             </a:r>
             <a:endParaRPr lang="en-US" dirty="0"/>
           </a:p>
@@ -1396,7 +1485,7 @@
           <a:p>
             <a:r>
               <a:rPr lang="en-US" dirty="0"/>
-              <a:t>Common gotcha — attendees pick a model, hit a region wall. Encourage confirming region + quota before deploying.</a:t>
+              <a:t>Show them where to grab this from the portal. Overview page → 'Endpoints and keys' or similar (verify current wording live).</a:t>
             </a:r>
             <a:endParaRPr lang="en-US" dirty="0"/>
           </a:p>
@@ -1484,7 +1573,7 @@
           <a:p>
             <a:r>
               <a:rPr lang="en-US" dirty="0"/>
-              <a:t>Deployment name != model name. Common source of confusion in the lab. Emphasize.</a:t>
+              <a:t>Common gotcha — attendees pick a model, hit a region wall. Encourage confirming region + quota before deploying.</a:t>
             </a:r>
             <a:endParaRPr lang="en-US" dirty="0"/>
           </a:p>
@@ -1572,7 +1661,7 @@
           <a:p>
             <a:r>
               <a:rPr lang="en-US" dirty="0"/>
-              <a:t>This is a debugging tip masquerading as a portal feature. Reinforce: iterate in the playground first.</a:t>
+              <a:t>Deployment name != model name. Common source of confusion in the lab. Emphasize.</a:t>
             </a:r>
             <a:endParaRPr lang="en-US" dirty="0"/>
           </a:p>
@@ -1660,7 +1749,7 @@
           <a:p>
             <a:r>
               <a:rPr lang="en-US" dirty="0"/>
-              <a:t>Just orient them. Deep material lands Day 2.</a:t>
+              <a:t>This is a debugging tip masquerading as a portal feature. Reinforce: iterate in the playground first.</a:t>
             </a:r>
             <a:endParaRPr lang="en-US" dirty="0"/>
           </a:p>
@@ -1748,7 +1837,7 @@
           <a:p>
             <a:r>
               <a:rPr lang="en-US" dirty="0"/>
-              <a:t>Transition to portal areas we introduce today and revisit later.</a:t>
+              <a:t>Reinforce the architecture slide: connections are Foundry's way of pointing at connected resources, which live under their own governance boundaries. If a Foundry-side connection fails, check the target resource's own network/access policies, not just Foundry's.</a:t>
             </a:r>
             <a:endParaRPr lang="en-US" dirty="0"/>
           </a:p>
@@ -2291,7 +2380,7 @@
     <p:bg>
       <p:bgPr>
         <a:solidFill>
-          <a:srgbClr val="FFFFFF"/>
+          <a:srgbClr val="1E2761"/>
         </a:solidFill>
       </p:bgPr>
     </p:bg>
@@ -2311,34 +2400,14 @@
       </p:grpSpPr>
       <p:sp>
         <p:nvSpPr>
-          <p:cNvPr id="2" name="Shape 0"/>
-          <p:cNvSpPr/>
-          <p:nvPr/>
-        </p:nvSpPr>
-        <p:spPr>
-          <a:xfrm>
-            <a:off x="0" y="0"/>
-            <a:ext cx="54864" cy="5143500"/>
-          </a:xfrm>
-          <a:prstGeom prst="rect">
-            <a:avLst/>
-          </a:prstGeom>
-          <a:solidFill>
-            <a:srgbClr val="1E2761"/>
-          </a:solidFill>
-          <a:ln/>
-        </p:spPr>
-      </p:sp>
-      <p:sp>
-        <p:nvSpPr>
-          <p:cNvPr id="3" name="Text 1"/>
-          <p:cNvSpPr/>
-          <p:nvPr/>
-        </p:nvSpPr>
-        <p:spPr>
-          <a:xfrm>
-            <a:off x="5669280" y="274320"/>
-            <a:ext cx="3291840" cy="274320"/>
+          <p:cNvPr id="2" name="Text 0"/>
+          <p:cNvSpPr/>
+          <p:nvPr/>
+        </p:nvSpPr>
+        <p:spPr>
+          <a:xfrm>
+            <a:off x="548640" y="2011680"/>
+            <a:ext cx="8046720" cy="1097280"/>
           </a:xfrm>
           <a:prstGeom prst="rect">
             <a:avLst/>
@@ -2347,76 +2416,37 @@
           <a:ln/>
         </p:spPr>
         <p:txBody>
-          <a:bodyPr wrap="square" lIns="0" tIns="0" rIns="0" bIns="0" rtlCol="0" anchor="ctr"/>
-          <a:lstStyle/>
-          <a:p>
-            <a:pPr algn="r" indent="0" marL="0">
-              <a:buNone/>
-            </a:pPr>
-            <a:r>
-              <a:rPr lang="en-US" sz="1000" dirty="0">
-                <a:solidFill>
-                  <a:srgbClr val="6B7280"/>
-                </a:solidFill>
-                <a:latin typeface="Calibri" pitchFamily="34" charset="0"/>
-                <a:ea typeface="Calibri" pitchFamily="34" charset="-122"/>
-                <a:cs typeface="Calibri" pitchFamily="34" charset="-120"/>
-              </a:rPr>
-              <a:t>Day 1 · Module 2</a:t>
-            </a:r>
-            <a:endParaRPr lang="en-US" sz="1000" dirty="0"/>
-          </a:p>
-        </p:txBody>
-      </p:sp>
-      <p:sp>
-        <p:nvSpPr>
-          <p:cNvPr id="4" name="Text 2"/>
-          <p:cNvSpPr/>
-          <p:nvPr/>
-        </p:nvSpPr>
-        <p:spPr>
-          <a:xfrm>
-            <a:off x="365760" y="320040"/>
-            <a:ext cx="6217920" cy="640080"/>
-          </a:xfrm>
-          <a:prstGeom prst="rect">
-            <a:avLst/>
-          </a:prstGeom>
-          <a:noFill/>
-          <a:ln/>
-        </p:spPr>
-        <p:txBody>
-          <a:bodyPr wrap="square" lIns="0" tIns="0" rIns="0" bIns="0" rtlCol="0" anchor="ctr"/>
+          <a:bodyPr wrap="square" rtlCol="0" anchor="ctr"/>
           <a:lstStyle/>
           <a:p>
             <a:pPr indent="0" marL="0">
               <a:buNone/>
             </a:pPr>
             <a:r>
-              <a:rPr lang="en-US" sz="2800" b="1" dirty="0">
-                <a:solidFill>
-                  <a:srgbClr val="1E2761"/>
-                </a:solidFill>
-                <a:latin typeface="Calibri" pitchFamily="34" charset="0"/>
-                <a:ea typeface="Calibri" pitchFamily="34" charset="-122"/>
-                <a:cs typeface="Calibri" pitchFamily="34" charset="-120"/>
-              </a:rPr>
-              <a:t>Foundry Toolbox (intro)</a:t>
-            </a:r>
-            <a:endParaRPr lang="en-US" sz="2800" dirty="0"/>
-          </a:p>
-        </p:txBody>
-      </p:sp>
-      <p:sp>
-        <p:nvSpPr>
-          <p:cNvPr id="5" name="Text 3"/>
-          <p:cNvSpPr/>
-          <p:nvPr/>
-        </p:nvSpPr>
-        <p:spPr>
-          <a:xfrm>
-            <a:off x="365760" y="1097280"/>
-            <a:ext cx="8412480" cy="3749040"/>
+              <a:rPr lang="en-US" sz="4000" b="1" dirty="0">
+                <a:solidFill>
+                  <a:srgbClr val="FFFFFF"/>
+                </a:solidFill>
+                <a:latin typeface="Calibri" pitchFamily="34" charset="0"/>
+                <a:ea typeface="Calibri" pitchFamily="34" charset="-122"/>
+                <a:cs typeface="Calibri" pitchFamily="34" charset="-120"/>
+              </a:rPr>
+              <a:t>Toolbox and Foundry IQ</a:t>
+            </a:r>
+            <a:endParaRPr lang="en-US" sz="4000" dirty="0"/>
+          </a:p>
+        </p:txBody>
+      </p:sp>
+      <p:sp>
+        <p:nvSpPr>
+          <p:cNvPr id="3" name="Text 1"/>
+          <p:cNvSpPr/>
+          <p:nvPr/>
+        </p:nvSpPr>
+        <p:spPr>
+          <a:xfrm>
+            <a:off x="548640" y="3108960"/>
+            <a:ext cx="8046720" cy="548640"/>
           </a:xfrm>
           <a:prstGeom prst="rect">
             <a:avLst/>
@@ -2428,88 +2458,21 @@
           <a:bodyPr wrap="square" rtlCol="0" anchor="ctr"/>
           <a:lstStyle/>
           <a:p>
-            <a:pPr marL="342900" indent="-342900">
-              <a:spcAft>
-                <a:spcPts val="600"/>
-              </a:spcAft>
-              <a:buSzPct val="100000"/>
-              <a:buChar char="•"/>
-            </a:pPr>
-            <a:r>
-              <a:rPr lang="en-US" sz="1500" dirty="0">
-                <a:solidFill>
-                  <a:srgbClr val="212121"/>
-                </a:solidFill>
-                <a:latin typeface="Calibri" pitchFamily="34" charset="0"/>
-                <a:ea typeface="Calibri" pitchFamily="34" charset="-122"/>
-                <a:cs typeface="Calibri" pitchFamily="34" charset="-120"/>
-              </a:rPr>
-              <a:t>Curated catalog of ready-to-use tools an agent can attach to</a:t>
-            </a:r>
-            <a:endParaRPr lang="en-US" sz="1500" dirty="0"/>
-          </a:p>
-          <a:p>
-            <a:pPr marL="342900" indent="-342900">
-              <a:spcAft>
-                <a:spcPts val="600"/>
-              </a:spcAft>
-              <a:buSzPct val="100000"/>
-              <a:buChar char="•"/>
-            </a:pPr>
-            <a:r>
-              <a:rPr lang="en-US" sz="1500" dirty="0">
-                <a:solidFill>
-                  <a:srgbClr val="212121"/>
-                </a:solidFill>
-                <a:latin typeface="Calibri" pitchFamily="34" charset="0"/>
-                <a:ea typeface="Calibri" pitchFamily="34" charset="-122"/>
-                <a:cs typeface="Calibri" pitchFamily="34" charset="-120"/>
-              </a:rPr>
-              <a:t>Includes: code interpreter, file search, Bing search, SharePoint, Fabric, Graph, custom skills</a:t>
-            </a:r>
-            <a:endParaRPr lang="en-US" sz="1500" dirty="0"/>
-          </a:p>
-          <a:p>
-            <a:pPr marL="342900" indent="-342900">
-              <a:spcAft>
-                <a:spcPts val="600"/>
-              </a:spcAft>
-              <a:buSzPct val="100000"/>
-              <a:buChar char="•"/>
-            </a:pPr>
-            <a:r>
-              <a:rPr lang="en-US" sz="1500" dirty="0">
-                <a:solidFill>
-                  <a:srgbClr val="212121"/>
-                </a:solidFill>
-                <a:latin typeface="Calibri" pitchFamily="34" charset="0"/>
-                <a:ea typeface="Calibri" pitchFamily="34" charset="-122"/>
-                <a:cs typeface="Calibri" pitchFamily="34" charset="-120"/>
-              </a:rPr>
-              <a:t>Exposed to MAF over an MCP endpoint (same protocol as Day 3)</a:t>
-            </a:r>
-            <a:endParaRPr lang="en-US" sz="1500" dirty="0"/>
-          </a:p>
-          <a:p>
-            <a:pPr marL="342900" indent="-342900">
-              <a:spcAft>
-                <a:spcPts val="600"/>
-              </a:spcAft>
-              <a:buSzPct val="100000"/>
-              <a:buChar char="•"/>
-            </a:pPr>
-            <a:r>
-              <a:rPr lang="en-US" sz="1500" dirty="0">
-                <a:solidFill>
-                  <a:srgbClr val="212121"/>
-                </a:solidFill>
-                <a:latin typeface="Calibri" pitchFamily="34" charset="0"/>
-                <a:ea typeface="Calibri" pitchFamily="34" charset="-122"/>
-                <a:cs typeface="Calibri" pitchFamily="34" charset="-120"/>
-              </a:rPr>
-              <a:t>Attach Toolbox tools to a Foundry-hosted agent from the portal, or from code</a:t>
-            </a:r>
-            <a:endParaRPr lang="en-US" sz="1500" dirty="0"/>
+            <a:pPr indent="0" marL="0">
+              <a:buNone/>
+            </a:pPr>
+            <a:r>
+              <a:rPr lang="en-US" sz="1800" dirty="0">
+                <a:solidFill>
+                  <a:srgbClr val="CADCFC"/>
+                </a:solidFill>
+                <a:latin typeface="Calibri" pitchFamily="34" charset="0"/>
+                <a:ea typeface="Calibri" pitchFamily="34" charset="-122"/>
+                <a:cs typeface="Calibri" pitchFamily="34" charset="-120"/>
+              </a:rPr>
+              <a:t>Introductions only — Days 2–3 go deep</a:t>
+            </a:r>
+            <a:endParaRPr lang="en-US" sz="1800" dirty="0"/>
           </a:p>
         </p:txBody>
       </p:sp>
@@ -2637,7 +2600,7 @@
                 <a:ea typeface="Calibri" pitchFamily="34" charset="-122"/>
                 <a:cs typeface="Calibri" pitchFamily="34" charset="-120"/>
               </a:rPr>
-              <a:t>Foundry IQ (intro)</a:t>
+              <a:t>Foundry Toolbox (intro)</a:t>
             </a:r>
             <a:endParaRPr lang="en-US" sz="2800" dirty="0"/>
           </a:p>
@@ -2680,7 +2643,7 @@
                 <a:ea typeface="Calibri" pitchFamily="34" charset="-122"/>
                 <a:cs typeface="Calibri" pitchFamily="34" charset="-120"/>
               </a:rPr>
-              <a:t>The knowledge / grounding layer of Foundry</a:t>
+              <a:t>Curated catalog of ready-to-use tools an agent can attach to</a:t>
             </a:r>
             <a:endParaRPr lang="en-US" sz="1500" dirty="0"/>
           </a:p>
@@ -2701,7 +2664,7 @@
                 <a:ea typeface="Calibri" pitchFamily="34" charset="-122"/>
                 <a:cs typeface="Calibri" pitchFamily="34" charset="-120"/>
               </a:rPr>
-              <a:t>Unified retrieval across enterprise sources — AI Search indexes, SharePoint, OneLake / Fabric, and more</a:t>
+              <a:t>Includes: code interpreter, file search, Bing search, SharePoint, Fabric, Graph, custom skills</a:t>
             </a:r>
             <a:endParaRPr lang="en-US" sz="1500" dirty="0"/>
           </a:p>
@@ -2722,7 +2685,7 @@
                 <a:ea typeface="Calibri" pitchFamily="34" charset="-122"/>
                 <a:cs typeface="Calibri" pitchFamily="34" charset="-120"/>
               </a:rPr>
-              <a:t>Alternative to hand-rolling a RAG pipeline per source</a:t>
+              <a:t>Exposed to MAF over an MCP endpoint (same protocol as Day 3)</a:t>
             </a:r>
             <a:endParaRPr lang="en-US" sz="1500" dirty="0"/>
           </a:p>
@@ -2743,7 +2706,7 @@
                 <a:ea typeface="Calibri" pitchFamily="34" charset="-122"/>
                 <a:cs typeface="Calibri" pitchFamily="34" charset="-120"/>
               </a:rPr>
-              <a:t>Agents that use it get grounded answers with citations, without you writing retrieval code</a:t>
+              <a:t>Attach Toolbox tools to a Foundry-hosted agent from the portal, or from code</a:t>
             </a:r>
             <a:endParaRPr lang="en-US" sz="1500" dirty="0"/>
           </a:p>
@@ -2873,6 +2836,242 @@
                 <a:ea typeface="Calibri" pitchFamily="34" charset="-122"/>
                 <a:cs typeface="Calibri" pitchFamily="34" charset="-120"/>
               </a:rPr>
+              <a:t>Foundry IQ (intro)</a:t>
+            </a:r>
+            <a:endParaRPr lang="en-US" sz="2800" dirty="0"/>
+          </a:p>
+        </p:txBody>
+      </p:sp>
+      <p:sp>
+        <p:nvSpPr>
+          <p:cNvPr id="5" name="Text 3"/>
+          <p:cNvSpPr/>
+          <p:nvPr/>
+        </p:nvSpPr>
+        <p:spPr>
+          <a:xfrm>
+            <a:off x="365760" y="1097280"/>
+            <a:ext cx="8412480" cy="3749040"/>
+          </a:xfrm>
+          <a:prstGeom prst="rect">
+            <a:avLst/>
+          </a:prstGeom>
+          <a:noFill/>
+          <a:ln/>
+        </p:spPr>
+        <p:txBody>
+          <a:bodyPr wrap="square" rtlCol="0" anchor="ctr"/>
+          <a:lstStyle/>
+          <a:p>
+            <a:pPr marL="342900" indent="-342900">
+              <a:spcAft>
+                <a:spcPts val="600"/>
+              </a:spcAft>
+              <a:buSzPct val="100000"/>
+              <a:buChar char="•"/>
+            </a:pPr>
+            <a:r>
+              <a:rPr lang="en-US" sz="1500" dirty="0">
+                <a:solidFill>
+                  <a:srgbClr val="212121"/>
+                </a:solidFill>
+                <a:latin typeface="Calibri" pitchFamily="34" charset="0"/>
+                <a:ea typeface="Calibri" pitchFamily="34" charset="-122"/>
+                <a:cs typeface="Calibri" pitchFamily="34" charset="-120"/>
+              </a:rPr>
+              <a:t>The knowledge / grounding layer of Foundry</a:t>
+            </a:r>
+            <a:endParaRPr lang="en-US" sz="1500" dirty="0"/>
+          </a:p>
+          <a:p>
+            <a:pPr marL="342900" indent="-342900">
+              <a:spcAft>
+                <a:spcPts val="600"/>
+              </a:spcAft>
+              <a:buSzPct val="100000"/>
+              <a:buChar char="•"/>
+            </a:pPr>
+            <a:r>
+              <a:rPr lang="en-US" sz="1500" dirty="0">
+                <a:solidFill>
+                  <a:srgbClr val="212121"/>
+                </a:solidFill>
+                <a:latin typeface="Calibri" pitchFamily="34" charset="0"/>
+                <a:ea typeface="Calibri" pitchFamily="34" charset="-122"/>
+                <a:cs typeface="Calibri" pitchFamily="34" charset="-120"/>
+              </a:rPr>
+              <a:t>Unified retrieval across enterprise sources — AI Search indexes, SharePoint, OneLake / Fabric, and more</a:t>
+            </a:r>
+            <a:endParaRPr lang="en-US" sz="1500" dirty="0"/>
+          </a:p>
+          <a:p>
+            <a:pPr marL="342900" indent="-342900">
+              <a:spcAft>
+                <a:spcPts val="600"/>
+              </a:spcAft>
+              <a:buSzPct val="100000"/>
+              <a:buChar char="•"/>
+            </a:pPr>
+            <a:r>
+              <a:rPr lang="en-US" sz="1500" dirty="0">
+                <a:solidFill>
+                  <a:srgbClr val="212121"/>
+                </a:solidFill>
+                <a:latin typeface="Calibri" pitchFamily="34" charset="0"/>
+                <a:ea typeface="Calibri" pitchFamily="34" charset="-122"/>
+                <a:cs typeface="Calibri" pitchFamily="34" charset="-120"/>
+              </a:rPr>
+              <a:t>Alternative to hand-rolling a RAG pipeline per source</a:t>
+            </a:r>
+            <a:endParaRPr lang="en-US" sz="1500" dirty="0"/>
+          </a:p>
+          <a:p>
+            <a:pPr marL="342900" indent="-342900">
+              <a:spcAft>
+                <a:spcPts val="600"/>
+              </a:spcAft>
+              <a:buSzPct val="100000"/>
+              <a:buChar char="•"/>
+            </a:pPr>
+            <a:r>
+              <a:rPr lang="en-US" sz="1500" dirty="0">
+                <a:solidFill>
+                  <a:srgbClr val="212121"/>
+                </a:solidFill>
+                <a:latin typeface="Calibri" pitchFamily="34" charset="0"/>
+                <a:ea typeface="Calibri" pitchFamily="34" charset="-122"/>
+                <a:cs typeface="Calibri" pitchFamily="34" charset="-120"/>
+              </a:rPr>
+              <a:t>Agents that use it get grounded answers with citations, without you writing retrieval code</a:t>
+            </a:r>
+            <a:endParaRPr lang="en-US" sz="1500" dirty="0"/>
+          </a:p>
+        </p:txBody>
+      </p:sp>
+    </p:spTree>
+  </p:cSld>
+  <p:clrMapOvr>
+    <a:masterClrMapping/>
+  </p:clrMapOvr>
+</p:sld>
+</file>
+
+<file path=ppt/slides/slide13.xml><?xml version="1.0" encoding="utf-8"?>
+<p:sld xmlns:a="http://schemas.openxmlformats.org/drawingml/2006/main" xmlns:r="http://schemas.openxmlformats.org/officeDocument/2006/relationships" xmlns:p="http://schemas.openxmlformats.org/presentationml/2006/main">
+  <p:cSld name="Slide 13">
+    <p:bg>
+      <p:bgPr>
+        <a:solidFill>
+          <a:srgbClr val="FFFFFF"/>
+        </a:solidFill>
+      </p:bgPr>
+    </p:bg>
+    <p:spTree>
+      <p:nvGrpSpPr>
+        <p:cNvPr id="1" name=""/>
+        <p:cNvGrpSpPr/>
+        <p:nvPr/>
+      </p:nvGrpSpPr>
+      <p:grpSpPr>
+        <a:xfrm>
+          <a:off x="0" y="0"/>
+          <a:ext cx="0" cy="0"/>
+          <a:chOff x="0" y="0"/>
+          <a:chExt cx="0" cy="0"/>
+        </a:xfrm>
+      </p:grpSpPr>
+      <p:sp>
+        <p:nvSpPr>
+          <p:cNvPr id="2" name="Shape 0"/>
+          <p:cNvSpPr/>
+          <p:nvPr/>
+        </p:nvSpPr>
+        <p:spPr>
+          <a:xfrm>
+            <a:off x="0" y="0"/>
+            <a:ext cx="54864" cy="5143500"/>
+          </a:xfrm>
+          <a:prstGeom prst="rect">
+            <a:avLst/>
+          </a:prstGeom>
+          <a:solidFill>
+            <a:srgbClr val="1E2761"/>
+          </a:solidFill>
+          <a:ln/>
+        </p:spPr>
+      </p:sp>
+      <p:sp>
+        <p:nvSpPr>
+          <p:cNvPr id="3" name="Text 1"/>
+          <p:cNvSpPr/>
+          <p:nvPr/>
+        </p:nvSpPr>
+        <p:spPr>
+          <a:xfrm>
+            <a:off x="5669280" y="274320"/>
+            <a:ext cx="3291840" cy="274320"/>
+          </a:xfrm>
+          <a:prstGeom prst="rect">
+            <a:avLst/>
+          </a:prstGeom>
+          <a:noFill/>
+          <a:ln/>
+        </p:spPr>
+        <p:txBody>
+          <a:bodyPr wrap="square" lIns="0" tIns="0" rIns="0" bIns="0" rtlCol="0" anchor="ctr"/>
+          <a:lstStyle/>
+          <a:p>
+            <a:pPr algn="r" indent="0" marL="0">
+              <a:buNone/>
+            </a:pPr>
+            <a:r>
+              <a:rPr lang="en-US" sz="1000" dirty="0">
+                <a:solidFill>
+                  <a:srgbClr val="6B7280"/>
+                </a:solidFill>
+                <a:latin typeface="Calibri" pitchFamily="34" charset="0"/>
+                <a:ea typeface="Calibri" pitchFamily="34" charset="-122"/>
+                <a:cs typeface="Calibri" pitchFamily="34" charset="-120"/>
+              </a:rPr>
+              <a:t>Day 1 · Module 2</a:t>
+            </a:r>
+            <a:endParaRPr lang="en-US" sz="1000" dirty="0"/>
+          </a:p>
+        </p:txBody>
+      </p:sp>
+      <p:sp>
+        <p:nvSpPr>
+          <p:cNvPr id="4" name="Text 2"/>
+          <p:cNvSpPr/>
+          <p:nvPr/>
+        </p:nvSpPr>
+        <p:spPr>
+          <a:xfrm>
+            <a:off x="365760" y="320040"/>
+            <a:ext cx="6217920" cy="640080"/>
+          </a:xfrm>
+          <a:prstGeom prst="rect">
+            <a:avLst/>
+          </a:prstGeom>
+          <a:noFill/>
+          <a:ln/>
+        </p:spPr>
+        <p:txBody>
+          <a:bodyPr wrap="square" lIns="0" tIns="0" rIns="0" bIns="0" rtlCol="0" anchor="ctr"/>
+          <a:lstStyle/>
+          <a:p>
+            <a:pPr indent="0" marL="0">
+              <a:buNone/>
+            </a:pPr>
+            <a:r>
+              <a:rPr lang="en-US" sz="2800" b="1" dirty="0">
+                <a:solidFill>
+                  <a:srgbClr val="1E2761"/>
+                </a:solidFill>
+                <a:latin typeface="Calibri" pitchFamily="34" charset="0"/>
+                <a:ea typeface="Calibri" pitchFamily="34" charset="-122"/>
+                <a:cs typeface="Calibri" pitchFamily="34" charset="-120"/>
+              </a:rPr>
               <a:t>Two axes to remember</a:t>
             </a:r>
             <a:endParaRPr lang="en-US" sz="2800" dirty="0"/>
@@ -2881,7 +3080,7 @@
       </p:sp>
       <p:graphicFrame>
         <p:nvGraphicFramePr>
-          <p:cNvPr id="13" name="Table 0"/>
+          <p:cNvPr id="14" name="Table 0"/>
           <p:cNvGraphicFramePr>
             <a:graphicFrameLocks noGrp="1"/>
           </p:cNvGraphicFramePr>
@@ -3536,242 +3735,6 @@
 </p:sld>
 </file>
 
-<file path=ppt/slides/slide13.xml><?xml version="1.0" encoding="utf-8"?>
-<p:sld xmlns:a="http://schemas.openxmlformats.org/drawingml/2006/main" xmlns:r="http://schemas.openxmlformats.org/officeDocument/2006/relationships" xmlns:p="http://schemas.openxmlformats.org/presentationml/2006/main">
-  <p:cSld name="Slide 13">
-    <p:bg>
-      <p:bgPr>
-        <a:solidFill>
-          <a:srgbClr val="FFFFFF"/>
-        </a:solidFill>
-      </p:bgPr>
-    </p:bg>
-    <p:spTree>
-      <p:nvGrpSpPr>
-        <p:cNvPr id="1" name=""/>
-        <p:cNvGrpSpPr/>
-        <p:nvPr/>
-      </p:nvGrpSpPr>
-      <p:grpSpPr>
-        <a:xfrm>
-          <a:off x="0" y="0"/>
-          <a:ext cx="0" cy="0"/>
-          <a:chOff x="0" y="0"/>
-          <a:chExt cx="0" cy="0"/>
-        </a:xfrm>
-      </p:grpSpPr>
-      <p:sp>
-        <p:nvSpPr>
-          <p:cNvPr id="2" name="Shape 0"/>
-          <p:cNvSpPr/>
-          <p:nvPr/>
-        </p:nvSpPr>
-        <p:spPr>
-          <a:xfrm>
-            <a:off x="0" y="0"/>
-            <a:ext cx="54864" cy="5143500"/>
-          </a:xfrm>
-          <a:prstGeom prst="rect">
-            <a:avLst/>
-          </a:prstGeom>
-          <a:solidFill>
-            <a:srgbClr val="1E2761"/>
-          </a:solidFill>
-          <a:ln/>
-        </p:spPr>
-      </p:sp>
-      <p:sp>
-        <p:nvSpPr>
-          <p:cNvPr id="3" name="Text 1"/>
-          <p:cNvSpPr/>
-          <p:nvPr/>
-        </p:nvSpPr>
-        <p:spPr>
-          <a:xfrm>
-            <a:off x="5669280" y="274320"/>
-            <a:ext cx="3291840" cy="274320"/>
-          </a:xfrm>
-          <a:prstGeom prst="rect">
-            <a:avLst/>
-          </a:prstGeom>
-          <a:noFill/>
-          <a:ln/>
-        </p:spPr>
-        <p:txBody>
-          <a:bodyPr wrap="square" lIns="0" tIns="0" rIns="0" bIns="0" rtlCol="0" anchor="ctr"/>
-          <a:lstStyle/>
-          <a:p>
-            <a:pPr algn="r" indent="0" marL="0">
-              <a:buNone/>
-            </a:pPr>
-            <a:r>
-              <a:rPr lang="en-US" sz="1000" dirty="0">
-                <a:solidFill>
-                  <a:srgbClr val="6B7280"/>
-                </a:solidFill>
-                <a:latin typeface="Calibri" pitchFamily="34" charset="0"/>
-                <a:ea typeface="Calibri" pitchFamily="34" charset="-122"/>
-                <a:cs typeface="Calibri" pitchFamily="34" charset="-120"/>
-              </a:rPr>
-              <a:t>Day 1 · Module 2</a:t>
-            </a:r>
-            <a:endParaRPr lang="en-US" sz="1000" dirty="0"/>
-          </a:p>
-        </p:txBody>
-      </p:sp>
-      <p:sp>
-        <p:nvSpPr>
-          <p:cNvPr id="4" name="Text 2"/>
-          <p:cNvSpPr/>
-          <p:nvPr/>
-        </p:nvSpPr>
-        <p:spPr>
-          <a:xfrm>
-            <a:off x="365760" y="320040"/>
-            <a:ext cx="6217920" cy="640080"/>
-          </a:xfrm>
-          <a:prstGeom prst="rect">
-            <a:avLst/>
-          </a:prstGeom>
-          <a:noFill/>
-          <a:ln/>
-        </p:spPr>
-        <p:txBody>
-          <a:bodyPr wrap="square" lIns="0" tIns="0" rIns="0" bIns="0" rtlCol="0" anchor="ctr"/>
-          <a:lstStyle/>
-          <a:p>
-            <a:pPr indent="0" marL="0">
-              <a:buNone/>
-            </a:pPr>
-            <a:r>
-              <a:rPr lang="en-US" sz="2800" b="1" dirty="0">
-                <a:solidFill>
-                  <a:srgbClr val="1E2761"/>
-                </a:solidFill>
-                <a:latin typeface="Calibri" pitchFamily="34" charset="0"/>
-                <a:ea typeface="Calibri" pitchFamily="34" charset="-122"/>
-                <a:cs typeface="Calibri" pitchFamily="34" charset="-120"/>
-              </a:rPr>
-              <a:t>Common portal gotchas</a:t>
-            </a:r>
-            <a:endParaRPr lang="en-US" sz="2800" dirty="0"/>
-          </a:p>
-        </p:txBody>
-      </p:sp>
-      <p:sp>
-        <p:nvSpPr>
-          <p:cNvPr id="5" name="Text 3"/>
-          <p:cNvSpPr/>
-          <p:nvPr/>
-        </p:nvSpPr>
-        <p:spPr>
-          <a:xfrm>
-            <a:off x="365760" y="1097280"/>
-            <a:ext cx="8412480" cy="3749040"/>
-          </a:xfrm>
-          <a:prstGeom prst="rect">
-            <a:avLst/>
-          </a:prstGeom>
-          <a:noFill/>
-          <a:ln/>
-        </p:spPr>
-        <p:txBody>
-          <a:bodyPr wrap="square" rtlCol="0" anchor="ctr"/>
-          <a:lstStyle/>
-          <a:p>
-            <a:pPr marL="342900" indent="-342900">
-              <a:spcAft>
-                <a:spcPts val="600"/>
-              </a:spcAft>
-              <a:buSzPct val="100000"/>
-              <a:buChar char="•"/>
-            </a:pPr>
-            <a:r>
-              <a:rPr lang="en-US" sz="1500" dirty="0">
-                <a:solidFill>
-                  <a:srgbClr val="212121"/>
-                </a:solidFill>
-                <a:latin typeface="Calibri" pitchFamily="34" charset="0"/>
-                <a:ea typeface="Calibri" pitchFamily="34" charset="-122"/>
-                <a:cs typeface="Calibri" pitchFamily="34" charset="-120"/>
-              </a:rPr>
-              <a:t>Quota errors on deployment — request a bump in the region before Day 1</a:t>
-            </a:r>
-            <a:endParaRPr lang="en-US" sz="1500" dirty="0"/>
-          </a:p>
-          <a:p>
-            <a:pPr marL="342900" indent="-342900">
-              <a:spcAft>
-                <a:spcPts val="600"/>
-              </a:spcAft>
-              <a:buSzPct val="100000"/>
-              <a:buChar char="•"/>
-            </a:pPr>
-            <a:r>
-              <a:rPr lang="en-US" sz="1500" dirty="0">
-                <a:solidFill>
-                  <a:srgbClr val="212121"/>
-                </a:solidFill>
-                <a:latin typeface="Calibri" pitchFamily="34" charset="0"/>
-                <a:ea typeface="Calibri" pitchFamily="34" charset="-122"/>
-                <a:cs typeface="Calibri" pitchFamily="34" charset="-120"/>
-              </a:rPr>
-              <a:t>Missing role assignments — attendees need at least Azure AI User on the project (401/403 usually means this)</a:t>
-            </a:r>
-            <a:endParaRPr lang="en-US" sz="1500" dirty="0"/>
-          </a:p>
-          <a:p>
-            <a:pPr marL="342900" indent="-342900">
-              <a:spcAft>
-                <a:spcPts val="600"/>
-              </a:spcAft>
-              <a:buSzPct val="100000"/>
-              <a:buChar char="•"/>
-            </a:pPr>
-            <a:r>
-              <a:rPr lang="en-US" sz="1500" dirty="0">
-                <a:solidFill>
-                  <a:srgbClr val="212121"/>
-                </a:solidFill>
-                <a:latin typeface="Calibri" pitchFamily="34" charset="0"/>
-                <a:ea typeface="Calibri" pitchFamily="34" charset="-122"/>
-                <a:cs typeface="Calibri" pitchFamily="34" charset="-120"/>
-              </a:rPr>
-              <a:t>Region mismatch — model deployment region must be reachable by IQ / AI Search</a:t>
-            </a:r>
-            <a:endParaRPr lang="en-US" sz="1500" dirty="0"/>
-          </a:p>
-          <a:p>
-            <a:pPr marL="342900" indent="-342900">
-              <a:spcAft>
-                <a:spcPts val="600"/>
-              </a:spcAft>
-              <a:buSzPct val="100000"/>
-              <a:buChar char="•"/>
-            </a:pPr>
-            <a:r>
-              <a:rPr lang="en-US" sz="1500" dirty="0">
-                <a:solidFill>
-                  <a:srgbClr val="212121"/>
-                </a:solidFill>
-                <a:latin typeface="Calibri" pitchFamily="34" charset="0"/>
-                <a:ea typeface="Calibri" pitchFamily="34" charset="-122"/>
-                <a:cs typeface="Calibri" pitchFamily="34" charset="-120"/>
-              </a:rPr>
-              <a:t>Preview features move — Toolbox and parts of IQ are evolving; trust running code over screenshots</a:t>
-            </a:r>
-            <a:endParaRPr lang="en-US" sz="1500" dirty="0"/>
-          </a:p>
-        </p:txBody>
-      </p:sp>
-    </p:spTree>
-  </p:cSld>
-  <p:clrMapOvr>
-    <a:masterClrMapping/>
-  </p:clrMapOvr>
-</p:sld>
-</file>
-
 <file path=ppt/slides/slide14.xml><?xml version="1.0" encoding="utf-8"?>
 <p:sld xmlns:a="http://schemas.openxmlformats.org/drawingml/2006/main" xmlns:r="http://schemas.openxmlformats.org/officeDocument/2006/relationships" xmlns:p="http://schemas.openxmlformats.org/presentationml/2006/main">
   <p:cSld name="Slide 14">
@@ -3888,7 +3851,7 @@
                 <a:ea typeface="Calibri" pitchFamily="34" charset="-122"/>
                 <a:cs typeface="Calibri" pitchFamily="34" charset="-120"/>
               </a:rPr>
-              <a:t>Live walkthrough (in the portal now)</a:t>
+              <a:t>Common portal gotchas</a:t>
             </a:r>
             <a:endParaRPr lang="en-US" sz="2800" dirty="0"/>
           </a:p>
@@ -3931,7 +3894,7 @@
                 <a:ea typeface="Calibri" pitchFamily="34" charset="-122"/>
                 <a:cs typeface="Calibri" pitchFamily="34" charset="-120"/>
               </a:rPr>
-              <a:t>Sign into ai.azure.com and open a project</a:t>
+              <a:t>Quota errors on deployment — request a bump in the region before Day 1</a:t>
             </a:r>
             <a:endParaRPr lang="en-US" sz="1500" dirty="0"/>
           </a:p>
@@ -3952,7 +3915,7 @@
                 <a:ea typeface="Calibri" pitchFamily="34" charset="-122"/>
                 <a:cs typeface="Calibri" pitchFamily="34" charset="-120"/>
               </a:rPr>
-              <a:t>Deploy a model</a:t>
+              <a:t>Missing role assignments — attendees need at least Foundry User (previously Azure AI User) at the Foundry resource scope; 401/403 usually means this</a:t>
             </a:r>
             <a:endParaRPr lang="en-US" sz="1500" dirty="0"/>
           </a:p>
@@ -3973,7 +3936,7 @@
                 <a:ea typeface="Calibri" pitchFamily="34" charset="-122"/>
                 <a:cs typeface="Calibri" pitchFamily="34" charset="-120"/>
               </a:rPr>
-              <a:t>Copy the project endpoint</a:t>
+              <a:t>Region mismatch — model deployment region must be reachable by IQ / AI Search</a:t>
             </a:r>
             <a:endParaRPr lang="en-US" sz="1500" dirty="0"/>
           </a:p>
@@ -3994,90 +3957,9 @@
                 <a:ea typeface="Calibri" pitchFamily="34" charset="-122"/>
                 <a:cs typeface="Calibri" pitchFamily="34" charset="-120"/>
               </a:rPr>
-              <a:t>Open the chat playground; send a test prompt</a:t>
+              <a:t>Preview features move — Toolbox and parts of IQ are evolving; trust running code over screenshots</a:t>
             </a:r>
             <a:endParaRPr lang="en-US" sz="1500" dirty="0"/>
-          </a:p>
-          <a:p>
-            <a:pPr marL="342900" indent="-342900">
-              <a:spcAft>
-                <a:spcPts val="600"/>
-              </a:spcAft>
-              <a:buSzPct val="100000"/>
-              <a:buChar char="•"/>
-            </a:pPr>
-            <a:r>
-              <a:rPr lang="en-US" sz="1500" dirty="0">
-                <a:solidFill>
-                  <a:srgbClr val="212121"/>
-                </a:solidFill>
-                <a:latin typeface="Calibri" pitchFamily="34" charset="0"/>
-                <a:ea typeface="Calibri" pitchFamily="34" charset="-122"/>
-                <a:cs typeface="Calibri" pitchFamily="34" charset="-120"/>
-              </a:rPr>
-              <a:t>Show the Toolbox catalog and one entry</a:t>
-            </a:r>
-            <a:endParaRPr lang="en-US" sz="1500" dirty="0"/>
-          </a:p>
-          <a:p>
-            <a:pPr marL="342900" indent="-342900">
-              <a:spcAft>
-                <a:spcPts val="600"/>
-              </a:spcAft>
-              <a:buSzPct val="100000"/>
-              <a:buChar char="•"/>
-            </a:pPr>
-            <a:r>
-              <a:rPr lang="en-US" sz="1500" dirty="0">
-                <a:solidFill>
-                  <a:srgbClr val="212121"/>
-                </a:solidFill>
-                <a:latin typeface="Calibri" pitchFamily="34" charset="0"/>
-                <a:ea typeface="Calibri" pitchFamily="34" charset="-122"/>
-                <a:cs typeface="Calibri" pitchFamily="34" charset="-120"/>
-              </a:rPr>
-              <a:t>Show the Foundry IQ landing page and one pre-provisioned knowledge source</a:t>
-            </a:r>
-            <a:endParaRPr lang="en-US" sz="1500" dirty="0"/>
-          </a:p>
-        </p:txBody>
-      </p:sp>
-      <p:sp>
-        <p:nvSpPr>
-          <p:cNvPr id="6" name="Text 4"/>
-          <p:cNvSpPr/>
-          <p:nvPr/>
-        </p:nvSpPr>
-        <p:spPr>
-          <a:xfrm>
-            <a:off x="365760" y="4206240"/>
-            <a:ext cx="8412480" cy="457200"/>
-          </a:xfrm>
-          <a:prstGeom prst="rect">
-            <a:avLst/>
-          </a:prstGeom>
-          <a:noFill/>
-          <a:ln/>
-        </p:spPr>
-        <p:txBody>
-          <a:bodyPr wrap="square" rtlCol="0" anchor="ctr"/>
-          <a:lstStyle/>
-          <a:p>
-            <a:pPr indent="0" marL="0">
-              <a:buNone/>
-            </a:pPr>
-            <a:r>
-              <a:rPr lang="en-US" sz="1400" b="1" i="1" dirty="0">
-                <a:solidFill>
-                  <a:srgbClr val="1E2761"/>
-                </a:solidFill>
-                <a:latin typeface="Calibri" pitchFamily="34" charset="0"/>
-                <a:ea typeface="Calibri" pitchFamily="34" charset="-122"/>
-                <a:cs typeface="Calibri" pitchFamily="34" charset="-120"/>
-              </a:rPr>
-              <a:t>Attendees: do steps 1–4 on your own sub before the module ends.</a:t>
-            </a:r>
-            <a:endParaRPr lang="en-US" sz="1400" dirty="0"/>
           </a:p>
         </p:txBody>
       </p:sp>
@@ -4205,6 +4087,323 @@
                 <a:ea typeface="Calibri" pitchFamily="34" charset="-122"/>
                 <a:cs typeface="Calibri" pitchFamily="34" charset="-120"/>
               </a:rPr>
+              <a:t>Live walkthrough (in the portal now)</a:t>
+            </a:r>
+            <a:endParaRPr lang="en-US" sz="2800" dirty="0"/>
+          </a:p>
+        </p:txBody>
+      </p:sp>
+      <p:sp>
+        <p:nvSpPr>
+          <p:cNvPr id="5" name="Text 3"/>
+          <p:cNvSpPr/>
+          <p:nvPr/>
+        </p:nvSpPr>
+        <p:spPr>
+          <a:xfrm>
+            <a:off x="365760" y="1097280"/>
+            <a:ext cx="8412480" cy="3749040"/>
+          </a:xfrm>
+          <a:prstGeom prst="rect">
+            <a:avLst/>
+          </a:prstGeom>
+          <a:noFill/>
+          <a:ln/>
+        </p:spPr>
+        <p:txBody>
+          <a:bodyPr wrap="square" rtlCol="0" anchor="ctr"/>
+          <a:lstStyle/>
+          <a:p>
+            <a:pPr marL="342900" indent="-342900">
+              <a:spcAft>
+                <a:spcPts val="600"/>
+              </a:spcAft>
+              <a:buSzPct val="100000"/>
+              <a:buChar char="•"/>
+            </a:pPr>
+            <a:r>
+              <a:rPr lang="en-US" sz="1500" dirty="0">
+                <a:solidFill>
+                  <a:srgbClr val="212121"/>
+                </a:solidFill>
+                <a:latin typeface="Calibri" pitchFamily="34" charset="0"/>
+                <a:ea typeface="Calibri" pitchFamily="34" charset="-122"/>
+                <a:cs typeface="Calibri" pitchFamily="34" charset="-120"/>
+              </a:rPr>
+              <a:t>Sign into ai.azure.com and open a project</a:t>
+            </a:r>
+            <a:endParaRPr lang="en-US" sz="1500" dirty="0"/>
+          </a:p>
+          <a:p>
+            <a:pPr marL="342900" indent="-342900">
+              <a:spcAft>
+                <a:spcPts val="600"/>
+              </a:spcAft>
+              <a:buSzPct val="100000"/>
+              <a:buChar char="•"/>
+            </a:pPr>
+            <a:r>
+              <a:rPr lang="en-US" sz="1500" dirty="0">
+                <a:solidFill>
+                  <a:srgbClr val="212121"/>
+                </a:solidFill>
+                <a:latin typeface="Calibri" pitchFamily="34" charset="0"/>
+                <a:ea typeface="Calibri" pitchFamily="34" charset="-122"/>
+                <a:cs typeface="Calibri" pitchFamily="34" charset="-120"/>
+              </a:rPr>
+              <a:t>Deploy a model</a:t>
+            </a:r>
+            <a:endParaRPr lang="en-US" sz="1500" dirty="0"/>
+          </a:p>
+          <a:p>
+            <a:pPr marL="342900" indent="-342900">
+              <a:spcAft>
+                <a:spcPts val="600"/>
+              </a:spcAft>
+              <a:buSzPct val="100000"/>
+              <a:buChar char="•"/>
+            </a:pPr>
+            <a:r>
+              <a:rPr lang="en-US" sz="1500" dirty="0">
+                <a:solidFill>
+                  <a:srgbClr val="212121"/>
+                </a:solidFill>
+                <a:latin typeface="Calibri" pitchFamily="34" charset="0"/>
+                <a:ea typeface="Calibri" pitchFamily="34" charset="-122"/>
+                <a:cs typeface="Calibri" pitchFamily="34" charset="-120"/>
+              </a:rPr>
+              <a:t>Copy the project endpoint</a:t>
+            </a:r>
+            <a:endParaRPr lang="en-US" sz="1500" dirty="0"/>
+          </a:p>
+          <a:p>
+            <a:pPr marL="342900" indent="-342900">
+              <a:spcAft>
+                <a:spcPts val="600"/>
+              </a:spcAft>
+              <a:buSzPct val="100000"/>
+              <a:buChar char="•"/>
+            </a:pPr>
+            <a:r>
+              <a:rPr lang="en-US" sz="1500" dirty="0">
+                <a:solidFill>
+                  <a:srgbClr val="212121"/>
+                </a:solidFill>
+                <a:latin typeface="Calibri" pitchFamily="34" charset="0"/>
+                <a:ea typeface="Calibri" pitchFamily="34" charset="-122"/>
+                <a:cs typeface="Calibri" pitchFamily="34" charset="-120"/>
+              </a:rPr>
+              <a:t>Open the chat playground; send a test prompt</a:t>
+            </a:r>
+            <a:endParaRPr lang="en-US" sz="1500" dirty="0"/>
+          </a:p>
+          <a:p>
+            <a:pPr marL="342900" indent="-342900">
+              <a:spcAft>
+                <a:spcPts val="600"/>
+              </a:spcAft>
+              <a:buSzPct val="100000"/>
+              <a:buChar char="•"/>
+            </a:pPr>
+            <a:r>
+              <a:rPr lang="en-US" sz="1500" dirty="0">
+                <a:solidFill>
+                  <a:srgbClr val="212121"/>
+                </a:solidFill>
+                <a:latin typeface="Calibri" pitchFamily="34" charset="0"/>
+                <a:ea typeface="Calibri" pitchFamily="34" charset="-122"/>
+                <a:cs typeface="Calibri" pitchFamily="34" charset="-120"/>
+              </a:rPr>
+              <a:t>Show the Toolbox catalog and one entry</a:t>
+            </a:r>
+            <a:endParaRPr lang="en-US" sz="1500" dirty="0"/>
+          </a:p>
+          <a:p>
+            <a:pPr marL="342900" indent="-342900">
+              <a:spcAft>
+                <a:spcPts val="600"/>
+              </a:spcAft>
+              <a:buSzPct val="100000"/>
+              <a:buChar char="•"/>
+            </a:pPr>
+            <a:r>
+              <a:rPr lang="en-US" sz="1500" dirty="0">
+                <a:solidFill>
+                  <a:srgbClr val="212121"/>
+                </a:solidFill>
+                <a:latin typeface="Calibri" pitchFamily="34" charset="0"/>
+                <a:ea typeface="Calibri" pitchFamily="34" charset="-122"/>
+                <a:cs typeface="Calibri" pitchFamily="34" charset="-120"/>
+              </a:rPr>
+              <a:t>Show the Foundry IQ landing page and one pre-provisioned knowledge source</a:t>
+            </a:r>
+            <a:endParaRPr lang="en-US" sz="1500" dirty="0"/>
+          </a:p>
+        </p:txBody>
+      </p:sp>
+      <p:sp>
+        <p:nvSpPr>
+          <p:cNvPr id="6" name="Text 4"/>
+          <p:cNvSpPr/>
+          <p:nvPr/>
+        </p:nvSpPr>
+        <p:spPr>
+          <a:xfrm>
+            <a:off x="365760" y="4206240"/>
+            <a:ext cx="8412480" cy="457200"/>
+          </a:xfrm>
+          <a:prstGeom prst="rect">
+            <a:avLst/>
+          </a:prstGeom>
+          <a:noFill/>
+          <a:ln/>
+        </p:spPr>
+        <p:txBody>
+          <a:bodyPr wrap="square" rtlCol="0" anchor="ctr"/>
+          <a:lstStyle/>
+          <a:p>
+            <a:pPr indent="0" marL="0">
+              <a:buNone/>
+            </a:pPr>
+            <a:r>
+              <a:rPr lang="en-US" sz="1400" b="1" i="1" dirty="0">
+                <a:solidFill>
+                  <a:srgbClr val="1E2761"/>
+                </a:solidFill>
+                <a:latin typeface="Calibri" pitchFamily="34" charset="0"/>
+                <a:ea typeface="Calibri" pitchFamily="34" charset="-122"/>
+                <a:cs typeface="Calibri" pitchFamily="34" charset="-120"/>
+              </a:rPr>
+              <a:t>Attendees: do steps 1–4 on your own sub before the module ends.</a:t>
+            </a:r>
+            <a:endParaRPr lang="en-US" sz="1400" dirty="0"/>
+          </a:p>
+        </p:txBody>
+      </p:sp>
+    </p:spTree>
+  </p:cSld>
+  <p:clrMapOvr>
+    <a:masterClrMapping/>
+  </p:clrMapOvr>
+</p:sld>
+</file>
+
+<file path=ppt/slides/slide16.xml><?xml version="1.0" encoding="utf-8"?>
+<p:sld xmlns:a="http://schemas.openxmlformats.org/drawingml/2006/main" xmlns:r="http://schemas.openxmlformats.org/officeDocument/2006/relationships" xmlns:p="http://schemas.openxmlformats.org/presentationml/2006/main">
+  <p:cSld name="Slide 16">
+    <p:bg>
+      <p:bgPr>
+        <a:solidFill>
+          <a:srgbClr val="FFFFFF"/>
+        </a:solidFill>
+      </p:bgPr>
+    </p:bg>
+    <p:spTree>
+      <p:nvGrpSpPr>
+        <p:cNvPr id="1" name=""/>
+        <p:cNvGrpSpPr/>
+        <p:nvPr/>
+      </p:nvGrpSpPr>
+      <p:grpSpPr>
+        <a:xfrm>
+          <a:off x="0" y="0"/>
+          <a:ext cx="0" cy="0"/>
+          <a:chOff x="0" y="0"/>
+          <a:chExt cx="0" cy="0"/>
+        </a:xfrm>
+      </p:grpSpPr>
+      <p:sp>
+        <p:nvSpPr>
+          <p:cNvPr id="2" name="Shape 0"/>
+          <p:cNvSpPr/>
+          <p:nvPr/>
+        </p:nvSpPr>
+        <p:spPr>
+          <a:xfrm>
+            <a:off x="0" y="0"/>
+            <a:ext cx="54864" cy="5143500"/>
+          </a:xfrm>
+          <a:prstGeom prst="rect">
+            <a:avLst/>
+          </a:prstGeom>
+          <a:solidFill>
+            <a:srgbClr val="1E2761"/>
+          </a:solidFill>
+          <a:ln/>
+        </p:spPr>
+      </p:sp>
+      <p:sp>
+        <p:nvSpPr>
+          <p:cNvPr id="3" name="Text 1"/>
+          <p:cNvSpPr/>
+          <p:nvPr/>
+        </p:nvSpPr>
+        <p:spPr>
+          <a:xfrm>
+            <a:off x="5669280" y="274320"/>
+            <a:ext cx="3291840" cy="274320"/>
+          </a:xfrm>
+          <a:prstGeom prst="rect">
+            <a:avLst/>
+          </a:prstGeom>
+          <a:noFill/>
+          <a:ln/>
+        </p:spPr>
+        <p:txBody>
+          <a:bodyPr wrap="square" lIns="0" tIns="0" rIns="0" bIns="0" rtlCol="0" anchor="ctr"/>
+          <a:lstStyle/>
+          <a:p>
+            <a:pPr algn="r" indent="0" marL="0">
+              <a:buNone/>
+            </a:pPr>
+            <a:r>
+              <a:rPr lang="en-US" sz="1000" dirty="0">
+                <a:solidFill>
+                  <a:srgbClr val="6B7280"/>
+                </a:solidFill>
+                <a:latin typeface="Calibri" pitchFamily="34" charset="0"/>
+                <a:ea typeface="Calibri" pitchFamily="34" charset="-122"/>
+                <a:cs typeface="Calibri" pitchFamily="34" charset="-120"/>
+              </a:rPr>
+              <a:t>Day 1 · Module 2</a:t>
+            </a:r>
+            <a:endParaRPr lang="en-US" sz="1000" dirty="0"/>
+          </a:p>
+        </p:txBody>
+      </p:sp>
+      <p:sp>
+        <p:nvSpPr>
+          <p:cNvPr id="4" name="Text 2"/>
+          <p:cNvSpPr/>
+          <p:nvPr/>
+        </p:nvSpPr>
+        <p:spPr>
+          <a:xfrm>
+            <a:off x="365760" y="320040"/>
+            <a:ext cx="6217920" cy="640080"/>
+          </a:xfrm>
+          <a:prstGeom prst="rect">
+            <a:avLst/>
+          </a:prstGeom>
+          <a:noFill/>
+          <a:ln/>
+        </p:spPr>
+        <p:txBody>
+          <a:bodyPr wrap="square" lIns="0" tIns="0" rIns="0" bIns="0" rtlCol="0" anchor="ctr"/>
+          <a:lstStyle/>
+          <a:p>
+            <a:pPr indent="0" marL="0">
+              <a:buNone/>
+            </a:pPr>
+            <a:r>
+              <a:rPr lang="en-US" sz="2800" b="1" dirty="0">
+                <a:solidFill>
+                  <a:srgbClr val="1E2761"/>
+                </a:solidFill>
+                <a:latin typeface="Calibri" pitchFamily="34" charset="0"/>
+                <a:ea typeface="Calibri" pitchFamily="34" charset="-122"/>
+                <a:cs typeface="Calibri" pitchFamily="34" charset="-120"/>
+              </a:rPr>
               <a:t>Takeaways</a:t>
             </a:r>
             <a:endParaRPr lang="en-US" sz="2800" dirty="0"/>
@@ -4771,7 +4970,7 @@
                 <a:ea typeface="Calibri" pitchFamily="34" charset="-122"/>
                 <a:cs typeface="Calibri" pitchFamily="34" charset="-120"/>
               </a:rPr>
-              <a:t>The Foundry hierarchy</a:t>
+              <a:t>Foundry resource architecture</a:t>
             </a:r>
             <a:endParaRPr lang="en-US" sz="2800" dirty="0"/>
           </a:p>
@@ -4779,14 +4978,39 @@
       </p:sp>
       <p:sp>
         <p:nvSpPr>
-          <p:cNvPr id="5" name="Text 3"/>
-          <p:cNvSpPr/>
-          <p:nvPr/>
-        </p:nvSpPr>
-        <p:spPr>
-          <a:xfrm>
-            <a:off x="365760" y="1097280"/>
-            <a:ext cx="8412480" cy="3749040"/>
+          <p:cNvPr id="5" name="Shape 3"/>
+          <p:cNvSpPr/>
+          <p:nvPr/>
+        </p:nvSpPr>
+        <p:spPr>
+          <a:xfrm>
+            <a:off x="365760" y="1051560"/>
+            <a:ext cx="5120640" cy="3108960"/>
+          </a:xfrm>
+          <a:prstGeom prst="rect">
+            <a:avLst/>
+          </a:prstGeom>
+          <a:solidFill>
+            <a:srgbClr val="FFFFFF"/>
+          </a:solidFill>
+          <a:ln w="25400">
+            <a:solidFill>
+              <a:srgbClr val="1E2761"/>
+            </a:solidFill>
+            <a:prstDash val="solid"/>
+          </a:ln>
+        </p:spPr>
+      </p:sp>
+      <p:sp>
+        <p:nvSpPr>
+          <p:cNvPr id="6" name="Text 4"/>
+          <p:cNvSpPr/>
+          <p:nvPr/>
+        </p:nvSpPr>
+        <p:spPr>
+          <a:xfrm>
+            <a:off x="457200" y="1124712"/>
+            <a:ext cx="4937760" cy="320040"/>
           </a:xfrm>
           <a:prstGeom prst="rect">
             <a:avLst/>
@@ -4795,18 +5019,300 @@
           <a:ln/>
         </p:spPr>
         <p:txBody>
-          <a:bodyPr wrap="square" rtlCol="0" anchor="ctr"/>
-          <a:lstStyle/>
-          <a:p>
-            <a:pPr marL="342900" indent="-342900">
-              <a:spcAft>
-                <a:spcPts val="600"/>
-              </a:spcAft>
-              <a:buSzPct val="100000"/>
-              <a:buChar char="•"/>
-            </a:pPr>
-            <a:r>
-              <a:rPr lang="en-US" sz="1500" dirty="0">
+          <a:bodyPr wrap="square" lIns="0" tIns="0" rIns="0" bIns="0" rtlCol="0" anchor="ctr"/>
+          <a:lstStyle/>
+          <a:p>
+            <a:pPr indent="0" marL="0">
+              <a:buNone/>
+            </a:pPr>
+            <a:r>
+              <a:rPr lang="en-US" sz="1300" b="1" dirty="0">
+                <a:solidFill>
+                  <a:srgbClr val="1E2761"/>
+                </a:solidFill>
+                <a:latin typeface="Calibri" pitchFamily="34" charset="0"/>
+                <a:ea typeface="Calibri" pitchFamily="34" charset="-122"/>
+                <a:cs typeface="Calibri" pitchFamily="34" charset="-120"/>
+              </a:rPr>
+              <a:t>Foundry resource · governance boundary</a:t>
+            </a:r>
+            <a:endParaRPr lang="en-US" sz="1300" dirty="0"/>
+          </a:p>
+        </p:txBody>
+      </p:sp>
+      <p:sp>
+        <p:nvSpPr>
+          <p:cNvPr id="7" name="Shape 5"/>
+          <p:cNvSpPr/>
+          <p:nvPr/>
+        </p:nvSpPr>
+        <p:spPr>
+          <a:xfrm>
+            <a:off x="502920" y="1554480"/>
+            <a:ext cx="1554480" cy="365760"/>
+          </a:xfrm>
+          <a:prstGeom prst="roundRect">
+            <a:avLst>
+              <a:gd name="adj" fmla="val 20000"/>
+            </a:avLst>
+          </a:prstGeom>
+          <a:solidFill>
+            <a:srgbClr val="CADCFC"/>
+          </a:solidFill>
+          <a:ln/>
+        </p:spPr>
+      </p:sp>
+      <p:sp>
+        <p:nvSpPr>
+          <p:cNvPr id="8" name="Text 6"/>
+          <p:cNvSpPr/>
+          <p:nvPr/>
+        </p:nvSpPr>
+        <p:spPr>
+          <a:xfrm>
+            <a:off x="502920" y="1554480"/>
+            <a:ext cx="1554480" cy="365760"/>
+          </a:xfrm>
+          <a:prstGeom prst="rect">
+            <a:avLst/>
+          </a:prstGeom>
+          <a:noFill/>
+          <a:ln/>
+        </p:spPr>
+        <p:txBody>
+          <a:bodyPr wrap="square" lIns="0" tIns="0" rIns="0" bIns="0" rtlCol="0" anchor="ctr"/>
+          <a:lstStyle/>
+          <a:p>
+            <a:pPr algn="ctr" indent="0" marL="0">
+              <a:buNone/>
+            </a:pPr>
+            <a:r>
+              <a:rPr lang="en-US" sz="1000" b="1" dirty="0">
+                <a:solidFill>
+                  <a:srgbClr val="1E2761"/>
+                </a:solidFill>
+                <a:latin typeface="Calibri" pitchFamily="34" charset="0"/>
+                <a:ea typeface="Calibri" pitchFamily="34" charset="-122"/>
+                <a:cs typeface="Calibri" pitchFamily="34" charset="-120"/>
+              </a:rPr>
+              <a:t>Model deployments</a:t>
+            </a:r>
+            <a:endParaRPr lang="en-US" sz="1000" dirty="0"/>
+          </a:p>
+        </p:txBody>
+      </p:sp>
+      <p:sp>
+        <p:nvSpPr>
+          <p:cNvPr id="9" name="Shape 7"/>
+          <p:cNvSpPr/>
+          <p:nvPr/>
+        </p:nvSpPr>
+        <p:spPr>
+          <a:xfrm>
+            <a:off x="2148840" y="1554480"/>
+            <a:ext cx="1554480" cy="365760"/>
+          </a:xfrm>
+          <a:prstGeom prst="roundRect">
+            <a:avLst>
+              <a:gd name="adj" fmla="val 20000"/>
+            </a:avLst>
+          </a:prstGeom>
+          <a:solidFill>
+            <a:srgbClr val="CADCFC"/>
+          </a:solidFill>
+          <a:ln/>
+        </p:spPr>
+      </p:sp>
+      <p:sp>
+        <p:nvSpPr>
+          <p:cNvPr id="10" name="Text 8"/>
+          <p:cNvSpPr/>
+          <p:nvPr/>
+        </p:nvSpPr>
+        <p:spPr>
+          <a:xfrm>
+            <a:off x="2148840" y="1554480"/>
+            <a:ext cx="1554480" cy="365760"/>
+          </a:xfrm>
+          <a:prstGeom prst="rect">
+            <a:avLst/>
+          </a:prstGeom>
+          <a:noFill/>
+          <a:ln/>
+        </p:spPr>
+        <p:txBody>
+          <a:bodyPr wrap="square" lIns="0" tIns="0" rIns="0" bIns="0" rtlCol="0" anchor="ctr"/>
+          <a:lstStyle/>
+          <a:p>
+            <a:pPr algn="ctr" indent="0" marL="0">
+              <a:buNone/>
+            </a:pPr>
+            <a:r>
+              <a:rPr lang="en-US" sz="1000" b="1" dirty="0">
+                <a:solidFill>
+                  <a:srgbClr val="1E2761"/>
+                </a:solidFill>
+                <a:latin typeface="Calibri" pitchFamily="34" charset="0"/>
+                <a:ea typeface="Calibri" pitchFamily="34" charset="-122"/>
+                <a:cs typeface="Calibri" pitchFamily="34" charset="-120"/>
+              </a:rPr>
+              <a:t>Security &amp; networking</a:t>
+            </a:r>
+            <a:endParaRPr lang="en-US" sz="1000" dirty="0"/>
+          </a:p>
+        </p:txBody>
+      </p:sp>
+      <p:sp>
+        <p:nvSpPr>
+          <p:cNvPr id="11" name="Shape 9"/>
+          <p:cNvSpPr/>
+          <p:nvPr/>
+        </p:nvSpPr>
+        <p:spPr>
+          <a:xfrm>
+            <a:off x="3794760" y="1554480"/>
+            <a:ext cx="1554480" cy="365760"/>
+          </a:xfrm>
+          <a:prstGeom prst="roundRect">
+            <a:avLst>
+              <a:gd name="adj" fmla="val 20000"/>
+            </a:avLst>
+          </a:prstGeom>
+          <a:solidFill>
+            <a:srgbClr val="CADCFC"/>
+          </a:solidFill>
+          <a:ln/>
+        </p:spPr>
+      </p:sp>
+      <p:sp>
+        <p:nvSpPr>
+          <p:cNvPr id="12" name="Text 10"/>
+          <p:cNvSpPr/>
+          <p:nvPr/>
+        </p:nvSpPr>
+        <p:spPr>
+          <a:xfrm>
+            <a:off x="3794760" y="1554480"/>
+            <a:ext cx="1554480" cy="365760"/>
+          </a:xfrm>
+          <a:prstGeom prst="rect">
+            <a:avLst/>
+          </a:prstGeom>
+          <a:noFill/>
+          <a:ln/>
+        </p:spPr>
+        <p:txBody>
+          <a:bodyPr wrap="square" lIns="0" tIns="0" rIns="0" bIns="0" rtlCol="0" anchor="ctr"/>
+          <a:lstStyle/>
+          <a:p>
+            <a:pPr algn="ctr" indent="0" marL="0">
+              <a:buNone/>
+            </a:pPr>
+            <a:r>
+              <a:rPr lang="en-US" sz="1000" b="1" dirty="0">
+                <a:solidFill>
+                  <a:srgbClr val="1E2761"/>
+                </a:solidFill>
+                <a:latin typeface="Calibri" pitchFamily="34" charset="0"/>
+                <a:ea typeface="Calibri" pitchFamily="34" charset="-122"/>
+                <a:cs typeface="Calibri" pitchFamily="34" charset="-120"/>
+              </a:rPr>
+              <a:t>Connections</a:t>
+            </a:r>
+            <a:endParaRPr lang="en-US" sz="1000" dirty="0"/>
+          </a:p>
+        </p:txBody>
+      </p:sp>
+      <p:sp>
+        <p:nvSpPr>
+          <p:cNvPr id="13" name="Shape 11"/>
+          <p:cNvSpPr/>
+          <p:nvPr/>
+        </p:nvSpPr>
+        <p:spPr>
+          <a:xfrm>
+            <a:off x="502920" y="2103120"/>
+            <a:ext cx="4846320" cy="1920240"/>
+          </a:xfrm>
+          <a:prstGeom prst="rect">
+            <a:avLst/>
+          </a:prstGeom>
+          <a:solidFill>
+            <a:srgbClr val="F3F4F6"/>
+          </a:solidFill>
+          <a:ln w="12700">
+            <a:solidFill>
+              <a:srgbClr val="1E2761"/>
+            </a:solidFill>
+            <a:prstDash val="dash"/>
+          </a:ln>
+        </p:spPr>
+      </p:sp>
+      <p:sp>
+        <p:nvSpPr>
+          <p:cNvPr id="14" name="Text 12"/>
+          <p:cNvSpPr/>
+          <p:nvPr/>
+        </p:nvSpPr>
+        <p:spPr>
+          <a:xfrm>
+            <a:off x="594360" y="2176272"/>
+            <a:ext cx="4663440" cy="292608"/>
+          </a:xfrm>
+          <a:prstGeom prst="rect">
+            <a:avLst/>
+          </a:prstGeom>
+          <a:noFill/>
+          <a:ln/>
+        </p:spPr>
+        <p:txBody>
+          <a:bodyPr wrap="square" lIns="0" tIns="0" rIns="0" bIns="0" rtlCol="0" anchor="ctr"/>
+          <a:lstStyle/>
+          <a:p>
+            <a:pPr indent="0" marL="0">
+              <a:buNone/>
+            </a:pPr>
+            <a:r>
+              <a:rPr lang="en-US" sz="1200" b="1" dirty="0">
+                <a:solidFill>
+                  <a:srgbClr val="1E2761"/>
+                </a:solidFill>
+                <a:latin typeface="Calibri" pitchFamily="34" charset="0"/>
+                <a:ea typeface="Calibri" pitchFamily="34" charset="-122"/>
+                <a:cs typeface="Calibri" pitchFamily="34" charset="-120"/>
+              </a:rPr>
+              <a:t>Project · development boundary</a:t>
+            </a:r>
+            <a:endParaRPr lang="en-US" sz="1200" dirty="0"/>
+          </a:p>
+        </p:txBody>
+      </p:sp>
+      <p:sp>
+        <p:nvSpPr>
+          <p:cNvPr id="15" name="Text 13"/>
+          <p:cNvSpPr/>
+          <p:nvPr/>
+        </p:nvSpPr>
+        <p:spPr>
+          <a:xfrm>
+            <a:off x="594360" y="2560320"/>
+            <a:ext cx="4663440" cy="457200"/>
+          </a:xfrm>
+          <a:prstGeom prst="rect">
+            <a:avLst/>
+          </a:prstGeom>
+          <a:noFill/>
+          <a:ln/>
+        </p:spPr>
+        <p:txBody>
+          <a:bodyPr wrap="square" lIns="0" tIns="0" rIns="0" bIns="0" rtlCol="0" anchor="ctr"/>
+          <a:lstStyle/>
+          <a:p>
+            <a:pPr indent="0" marL="0">
+              <a:buNone/>
+            </a:pPr>
+            <a:r>
+              <a:rPr lang="en-US" sz="1100" i="1" dirty="0">
                 <a:solidFill>
                   <a:srgbClr val="212121"/>
                 </a:solidFill>
@@ -4814,20 +5320,141 @@
                 <a:ea typeface="Calibri" pitchFamily="34" charset="-122"/>
                 <a:cs typeface="Calibri" pitchFamily="34" charset="-120"/>
               </a:rPr>
-              <a:t>Tenant — your Entra tenant</a:t>
-            </a:r>
-            <a:endParaRPr lang="en-US" sz="1500" dirty="0"/>
-          </a:p>
-          <a:p>
-            <a:pPr marL="342900" indent="-342900">
-              <a:spcAft>
-                <a:spcPts val="600"/>
-              </a:spcAft>
-              <a:buSzPct val="100000"/>
-              <a:buChar char="•"/>
-            </a:pPr>
-            <a:r>
-              <a:rPr lang="en-US" sz="1500" dirty="0">
+              <a:t>Project assets: files · agents · evaluations</a:t>
+            </a:r>
+            <a:endParaRPr lang="en-US" sz="1100" dirty="0"/>
+          </a:p>
+        </p:txBody>
+      </p:sp>
+      <p:sp>
+        <p:nvSpPr>
+          <p:cNvPr id="16" name="Text 14"/>
+          <p:cNvSpPr/>
+          <p:nvPr/>
+        </p:nvSpPr>
+        <p:spPr>
+          <a:xfrm>
+            <a:off x="5852160" y="1124712"/>
+            <a:ext cx="2926080" cy="274320"/>
+          </a:xfrm>
+          <a:prstGeom prst="rect">
+            <a:avLst/>
+          </a:prstGeom>
+          <a:noFill/>
+          <a:ln/>
+        </p:spPr>
+        <p:txBody>
+          <a:bodyPr wrap="square" lIns="0" tIns="0" rIns="0" bIns="0" rtlCol="0" anchor="ctr"/>
+          <a:lstStyle/>
+          <a:p>
+            <a:pPr indent="0" marL="0">
+              <a:buNone/>
+            </a:pPr>
+            <a:r>
+              <a:rPr lang="en-US" sz="1300" b="1" dirty="0">
+                <a:solidFill>
+                  <a:srgbClr val="1E2761"/>
+                </a:solidFill>
+                <a:latin typeface="Calibri" pitchFamily="34" charset="0"/>
+                <a:ea typeface="Calibri" pitchFamily="34" charset="-122"/>
+                <a:cs typeface="Calibri" pitchFamily="34" charset="-120"/>
+              </a:rPr>
+              <a:t>Connected resources</a:t>
+            </a:r>
+            <a:endParaRPr lang="en-US" sz="1300" dirty="0"/>
+          </a:p>
+        </p:txBody>
+      </p:sp>
+      <p:sp>
+        <p:nvSpPr>
+          <p:cNvPr id="17" name="Text 15"/>
+          <p:cNvSpPr/>
+          <p:nvPr/>
+        </p:nvSpPr>
+        <p:spPr>
+          <a:xfrm>
+            <a:off x="5852160" y="1417320"/>
+            <a:ext cx="2926080" cy="274320"/>
+          </a:xfrm>
+          <a:prstGeom prst="rect">
+            <a:avLst/>
+          </a:prstGeom>
+          <a:noFill/>
+          <a:ln/>
+        </p:spPr>
+        <p:txBody>
+          <a:bodyPr wrap="square" lIns="0" tIns="0" rIns="0" bIns="0" rtlCol="0" anchor="ctr"/>
+          <a:lstStyle/>
+          <a:p>
+            <a:pPr indent="0" marL="0">
+              <a:buNone/>
+            </a:pPr>
+            <a:r>
+              <a:rPr lang="en-US" sz="1000" i="1" dirty="0">
+                <a:solidFill>
+                  <a:srgbClr val="6B7280"/>
+                </a:solidFill>
+                <a:latin typeface="Calibri" pitchFamily="34" charset="0"/>
+                <a:ea typeface="Calibri" pitchFamily="34" charset="-122"/>
+                <a:cs typeface="Calibri" pitchFamily="34" charset="-120"/>
+              </a:rPr>
+              <a:t>separate Azure resources · own governance</a:t>
+            </a:r>
+            <a:endParaRPr lang="en-US" sz="1000" dirty="0"/>
+          </a:p>
+        </p:txBody>
+      </p:sp>
+      <p:sp>
+        <p:nvSpPr>
+          <p:cNvPr id="18" name="Shape 16"/>
+          <p:cNvSpPr/>
+          <p:nvPr/>
+        </p:nvSpPr>
+        <p:spPr>
+          <a:xfrm>
+            <a:off x="5852160" y="1828800"/>
+            <a:ext cx="2926080" cy="640080"/>
+          </a:xfrm>
+          <a:prstGeom prst="rect">
+            <a:avLst/>
+          </a:prstGeom>
+          <a:solidFill>
+            <a:srgbClr val="FFFFFF"/>
+          </a:solidFill>
+          <a:ln w="12700">
+            <a:solidFill>
+              <a:srgbClr val="D1D5DB"/>
+            </a:solidFill>
+            <a:prstDash val="dash"/>
+          </a:ln>
+        </p:spPr>
+      </p:sp>
+      <p:sp>
+        <p:nvSpPr>
+          <p:cNvPr id="19" name="Text 17"/>
+          <p:cNvSpPr/>
+          <p:nvPr/>
+        </p:nvSpPr>
+        <p:spPr>
+          <a:xfrm>
+            <a:off x="5852160" y="1828800"/>
+            <a:ext cx="2926080" cy="640080"/>
+          </a:xfrm>
+          <a:prstGeom prst="rect">
+            <a:avLst/>
+          </a:prstGeom>
+          <a:noFill/>
+          <a:ln/>
+        </p:spPr>
+        <p:txBody>
+          <a:bodyPr wrap="square" lIns="0" tIns="0" rIns="0" bIns="0" rtlCol="0" anchor="ctr"/>
+          <a:lstStyle/>
+          <a:p>
+            <a:pPr algn="ctr" indent="0" marL="0">
+              <a:buNone/>
+            </a:pPr>
+            <a:r>
+              <a:rPr lang="en-US" sz="1200" b="1" dirty="0">
                 <a:solidFill>
                   <a:srgbClr val="212121"/>
                 </a:solidFill>
@@ -4835,20 +5462,63 @@
                 <a:ea typeface="Calibri" pitchFamily="34" charset="-122"/>
                 <a:cs typeface="Calibri" pitchFamily="34" charset="-120"/>
               </a:rPr>
-              <a:t>Subscription — Azure subscription that pays for resources</a:t>
-            </a:r>
-            <a:endParaRPr lang="en-US" sz="1500" dirty="0"/>
-          </a:p>
-          <a:p>
-            <a:pPr marL="342900" indent="-342900">
-              <a:spcAft>
-                <a:spcPts val="600"/>
-              </a:spcAft>
-              <a:buSzPct val="100000"/>
-              <a:buChar char="•"/>
-            </a:pPr>
-            <a:r>
-              <a:rPr lang="en-US" sz="1500" dirty="0">
+              <a:t>Azure Storage</a:t>
+            </a:r>
+            <a:endParaRPr lang="en-US" sz="1200" dirty="0"/>
+          </a:p>
+        </p:txBody>
+      </p:sp>
+      <p:sp>
+        <p:nvSpPr>
+          <p:cNvPr id="20" name="Shape 18"/>
+          <p:cNvSpPr/>
+          <p:nvPr/>
+        </p:nvSpPr>
+        <p:spPr>
+          <a:xfrm>
+            <a:off x="5852160" y="2606040"/>
+            <a:ext cx="2926080" cy="640080"/>
+          </a:xfrm>
+          <a:prstGeom prst="rect">
+            <a:avLst/>
+          </a:prstGeom>
+          <a:solidFill>
+            <a:srgbClr val="FFFFFF"/>
+          </a:solidFill>
+          <a:ln w="12700">
+            <a:solidFill>
+              <a:srgbClr val="D1D5DB"/>
+            </a:solidFill>
+            <a:prstDash val="dash"/>
+          </a:ln>
+        </p:spPr>
+      </p:sp>
+      <p:sp>
+        <p:nvSpPr>
+          <p:cNvPr id="21" name="Text 19"/>
+          <p:cNvSpPr/>
+          <p:nvPr/>
+        </p:nvSpPr>
+        <p:spPr>
+          <a:xfrm>
+            <a:off x="5852160" y="2606040"/>
+            <a:ext cx="2926080" cy="640080"/>
+          </a:xfrm>
+          <a:prstGeom prst="rect">
+            <a:avLst/>
+          </a:prstGeom>
+          <a:noFill/>
+          <a:ln/>
+        </p:spPr>
+        <p:txBody>
+          <a:bodyPr wrap="square" lIns="0" tIns="0" rIns="0" bIns="0" rtlCol="0" anchor="ctr"/>
+          <a:lstStyle/>
+          <a:p>
+            <a:pPr algn="ctr" indent="0" marL="0">
+              <a:buNone/>
+            </a:pPr>
+            <a:r>
+              <a:rPr lang="en-US" sz="1200" b="1" dirty="0">
                 <a:solidFill>
                   <a:srgbClr val="212121"/>
                 </a:solidFill>
@@ -4856,20 +5526,63 @@
                 <a:ea typeface="Calibri" pitchFamily="34" charset="-122"/>
                 <a:cs typeface="Calibri" pitchFamily="34" charset="-120"/>
               </a:rPr>
-              <a:t>Resource group — where Foundry resources live</a:t>
-            </a:r>
-            <a:endParaRPr lang="en-US" sz="1500" dirty="0"/>
-          </a:p>
-          <a:p>
-            <a:pPr marL="342900" indent="-342900">
-              <a:spcAft>
-                <a:spcPts val="600"/>
-              </a:spcAft>
-              <a:buSzPct val="100000"/>
-              <a:buChar char="•"/>
-            </a:pPr>
-            <a:r>
-              <a:rPr lang="en-US" sz="1500" dirty="0">
+              <a:t>Azure Key Vault</a:t>
+            </a:r>
+            <a:endParaRPr lang="en-US" sz="1200" dirty="0"/>
+          </a:p>
+        </p:txBody>
+      </p:sp>
+      <p:sp>
+        <p:nvSpPr>
+          <p:cNvPr id="22" name="Shape 20"/>
+          <p:cNvSpPr/>
+          <p:nvPr/>
+        </p:nvSpPr>
+        <p:spPr>
+          <a:xfrm>
+            <a:off x="5852160" y="3383280"/>
+            <a:ext cx="2926080" cy="640080"/>
+          </a:xfrm>
+          <a:prstGeom prst="rect">
+            <a:avLst/>
+          </a:prstGeom>
+          <a:solidFill>
+            <a:srgbClr val="FFFFFF"/>
+          </a:solidFill>
+          <a:ln w="12700">
+            <a:solidFill>
+              <a:srgbClr val="D1D5DB"/>
+            </a:solidFill>
+            <a:prstDash val="dash"/>
+          </a:ln>
+        </p:spPr>
+      </p:sp>
+      <p:sp>
+        <p:nvSpPr>
+          <p:cNvPr id="23" name="Text 21"/>
+          <p:cNvSpPr/>
+          <p:nvPr/>
+        </p:nvSpPr>
+        <p:spPr>
+          <a:xfrm>
+            <a:off x="5852160" y="3383280"/>
+            <a:ext cx="2926080" cy="640080"/>
+          </a:xfrm>
+          <a:prstGeom prst="rect">
+            <a:avLst/>
+          </a:prstGeom>
+          <a:noFill/>
+          <a:ln/>
+        </p:spPr>
+        <p:txBody>
+          <a:bodyPr wrap="square" lIns="0" tIns="0" rIns="0" bIns="0" rtlCol="0" anchor="ctr"/>
+          <a:lstStyle/>
+          <a:p>
+            <a:pPr algn="ctr" indent="0" marL="0">
+              <a:buNone/>
+            </a:pPr>
+            <a:r>
+              <a:rPr lang="en-US" sz="1200" b="1" dirty="0">
                 <a:solidFill>
                   <a:srgbClr val="212121"/>
                 </a:solidFill>
@@ -4877,30 +5590,82 @@
                 <a:ea typeface="Calibri" pitchFamily="34" charset="-122"/>
                 <a:cs typeface="Calibri" pitchFamily="34" charset="-120"/>
               </a:rPr>
-              <a:t>Foundry project — the unit of collaboration; also the URL MAF connects to</a:t>
-            </a:r>
-            <a:endParaRPr lang="en-US" sz="1500" dirty="0"/>
-          </a:p>
-          <a:p>
-            <a:pPr marL="342900" indent="-342900">
-              <a:spcAft>
-                <a:spcPts val="600"/>
-              </a:spcAft>
-              <a:buSzPct val="100000"/>
-              <a:buChar char="•"/>
-            </a:pPr>
-            <a:r>
-              <a:rPr lang="en-US" sz="1500" dirty="0">
-                <a:solidFill>
-                  <a:srgbClr val="212121"/>
-                </a:solidFill>
-                <a:latin typeface="Calibri" pitchFamily="34" charset="0"/>
-                <a:ea typeface="Calibri" pitchFamily="34" charset="-122"/>
-                <a:cs typeface="Calibri" pitchFamily="34" charset="-120"/>
-              </a:rPr>
-              <a:t>Model deployments — instances of a specific model callable from your project</a:t>
-            </a:r>
-            <a:endParaRPr lang="en-US" sz="1500" dirty="0"/>
+              <a:t>Azure AI Search</a:t>
+            </a:r>
+            <a:endParaRPr lang="en-US" sz="1200" dirty="0"/>
+          </a:p>
+        </p:txBody>
+      </p:sp>
+      <p:sp>
+        <p:nvSpPr>
+          <p:cNvPr id="24" name="Shape 22"/>
+          <p:cNvSpPr/>
+          <p:nvPr/>
+        </p:nvSpPr>
+        <p:spPr>
+          <a:xfrm>
+            <a:off x="365760" y="4297680"/>
+            <a:ext cx="8412480" cy="502920"/>
+          </a:xfrm>
+          <a:prstGeom prst="rect">
+            <a:avLst/>
+          </a:prstGeom>
+          <a:solidFill>
+            <a:srgbClr val="CADCFC"/>
+          </a:solidFill>
+          <a:ln/>
+        </p:spPr>
+      </p:sp>
+      <p:sp>
+        <p:nvSpPr>
+          <p:cNvPr id="25" name="Text 23"/>
+          <p:cNvSpPr/>
+          <p:nvPr/>
+        </p:nvSpPr>
+        <p:spPr>
+          <a:xfrm>
+            <a:off x="502920" y="4343400"/>
+            <a:ext cx="8138160" cy="411480"/>
+          </a:xfrm>
+          <a:prstGeom prst="rect">
+            <a:avLst/>
+          </a:prstGeom>
+          <a:noFill/>
+          <a:ln/>
+        </p:spPr>
+        <p:txBody>
+          <a:bodyPr wrap="square" lIns="0" tIns="0" rIns="0" bIns="0" rtlCol="0" anchor="ctr"/>
+          <a:lstStyle/>
+          <a:p>
+            <a:pPr indent="0" marL="0">
+              <a:buNone/>
+            </a:pPr>
+            <a:r>
+              <a:rPr lang="en-US" sz="1200" b="1" dirty="0">
+                <a:solidFill>
+                  <a:srgbClr val="1E2761"/>
+                </a:solidFill>
+                <a:latin typeface="Calibri" pitchFamily="34" charset="0"/>
+                <a:ea typeface="Calibri" pitchFamily="34" charset="-122"/>
+                <a:cs typeface="Calibri" pitchFamily="34" charset="-120"/>
+              </a:rPr>
+              <a:t>Four layers to know: </a:t>
+            </a:r>
+            <a:pPr indent="0" marL="0">
+              <a:buNone/>
+            </a:pPr>
+            <a:r>
+              <a:rPr lang="en-US" sz="1200" dirty="0">
+                <a:solidFill>
+                  <a:srgbClr val="1E2761"/>
+                </a:solidFill>
+                <a:latin typeface="Calibri" pitchFamily="34" charset="0"/>
+                <a:ea typeface="Calibri" pitchFamily="34" charset="-122"/>
+                <a:cs typeface="Calibri" pitchFamily="34" charset="-120"/>
+              </a:rPr>
+              <a:t>Foundry resource → project → project assets → connected resources. Connected resources have their own networking and access policies.</a:t>
+            </a:r>
+            <a:endParaRPr lang="en-US" sz="1200" dirty="0"/>
           </a:p>
         </p:txBody>
       </p:sp>
@@ -5028,7 +5793,7 @@
                 <a:ea typeface="Calibri" pitchFamily="34" charset="-122"/>
                 <a:cs typeface="Calibri" pitchFamily="34" charset="-120"/>
               </a:rPr>
-              <a:t>Project endpoints</a:t>
+              <a:t>What lives where · starter RBAC</a:t>
             </a:r>
             <a:endParaRPr lang="en-US" sz="2800" dirty="0"/>
           </a:p>
@@ -5042,8 +5807,8 @@
         </p:nvSpPr>
         <p:spPr>
           <a:xfrm>
-            <a:off x="365760" y="1051560"/>
-            <a:ext cx="8412480" cy="365760"/>
+            <a:off x="365760" y="1097280"/>
+            <a:ext cx="4069080" cy="365760"/>
           </a:xfrm>
           <a:prstGeom prst="rect">
             <a:avLst/>
@@ -5052,62 +5817,37 @@
           <a:ln/>
         </p:spPr>
         <p:txBody>
-          <a:bodyPr wrap="square" rtlCol="0" anchor="ctr"/>
+          <a:bodyPr wrap="square" lIns="0" tIns="0" rIns="0" bIns="0" rtlCol="0" anchor="ctr"/>
           <a:lstStyle/>
           <a:p>
             <a:pPr indent="0" marL="0">
               <a:buNone/>
             </a:pPr>
             <a:r>
-              <a:rPr lang="en-US" sz="1500" dirty="0">
-                <a:solidFill>
-                  <a:srgbClr val="212121"/>
-                </a:solidFill>
-                <a:latin typeface="Calibri" pitchFamily="34" charset="0"/>
-                <a:ea typeface="Calibri" pitchFamily="34" charset="-122"/>
-                <a:cs typeface="Calibri" pitchFamily="34" charset="-120"/>
-              </a:rPr>
-              <a:t>Every Foundry project has an endpoint like:</a:t>
-            </a:r>
-            <a:endParaRPr lang="en-US" sz="1500" dirty="0"/>
-          </a:p>
-        </p:txBody>
-      </p:sp>
-      <p:sp>
-        <p:nvSpPr>
-          <p:cNvPr id="6" name="Shape 4"/>
-          <p:cNvSpPr/>
-          <p:nvPr/>
-        </p:nvSpPr>
-        <p:spPr>
-          <a:xfrm>
-            <a:off x="365760" y="1417320"/>
-            <a:ext cx="8412480" cy="548640"/>
-          </a:xfrm>
-          <a:prstGeom prst="rect">
-            <a:avLst/>
-          </a:prstGeom>
-          <a:solidFill>
-            <a:srgbClr val="F3F4F6"/>
-          </a:solidFill>
-          <a:ln w="6350">
-            <a:solidFill>
-              <a:srgbClr val="D1D5DB"/>
-            </a:solidFill>
-            <a:prstDash val="solid"/>
-          </a:ln>
-        </p:spPr>
-      </p:sp>
-      <p:sp>
-        <p:nvSpPr>
-          <p:cNvPr id="7" name="Text 5"/>
-          <p:cNvSpPr/>
-          <p:nvPr/>
-        </p:nvSpPr>
-        <p:spPr>
-          <a:xfrm>
-            <a:off x="502920" y="1508760"/>
-            <a:ext cx="8138160" cy="365760"/>
+              <a:rPr lang="en-US" sz="2000" b="1" dirty="0">
+                <a:solidFill>
+                  <a:srgbClr val="1E2761"/>
+                </a:solidFill>
+                <a:latin typeface="Calibri" pitchFamily="34" charset="0"/>
+                <a:ea typeface="Calibri" pitchFamily="34" charset="-122"/>
+                <a:cs typeface="Calibri" pitchFamily="34" charset="-120"/>
+              </a:rPr>
+              <a:t>Foundry resource level</a:t>
+            </a:r>
+            <a:endParaRPr lang="en-US" sz="2000" dirty="0"/>
+          </a:p>
+        </p:txBody>
+      </p:sp>
+      <p:sp>
+        <p:nvSpPr>
+          <p:cNvPr id="6" name="Text 4"/>
+          <p:cNvSpPr/>
+          <p:nvPr/>
+        </p:nvSpPr>
+        <p:spPr>
+          <a:xfrm>
+            <a:off x="4709160" y="1097280"/>
+            <a:ext cx="4069080" cy="365760"/>
           </a:xfrm>
           <a:prstGeom prst="rect">
             <a:avLst/>
@@ -5116,24 +5856,130 @@
           <a:ln/>
         </p:spPr>
         <p:txBody>
-          <a:bodyPr wrap="square" lIns="0" tIns="0" rIns="0" bIns="0" rtlCol="0" anchor="t"/>
+          <a:bodyPr wrap="square" lIns="0" tIns="0" rIns="0" bIns="0" rtlCol="0" anchor="ctr"/>
           <a:lstStyle/>
           <a:p>
             <a:pPr indent="0" marL="0">
               <a:buNone/>
             </a:pPr>
             <a:r>
-              <a:rPr lang="en-US" sz="1800" dirty="0">
+              <a:rPr lang="en-US" sz="2000" b="1" dirty="0">
+                <a:solidFill>
+                  <a:srgbClr val="1E2761"/>
+                </a:solidFill>
+                <a:latin typeface="Calibri" pitchFamily="34" charset="0"/>
+                <a:ea typeface="Calibri" pitchFamily="34" charset="-122"/>
+                <a:cs typeface="Calibri" pitchFamily="34" charset="-120"/>
+              </a:rPr>
+              <a:t>Project level</a:t>
+            </a:r>
+            <a:endParaRPr lang="en-US" sz="2000" dirty="0"/>
+          </a:p>
+        </p:txBody>
+      </p:sp>
+      <p:sp>
+        <p:nvSpPr>
+          <p:cNvPr id="7" name="Text 5"/>
+          <p:cNvSpPr/>
+          <p:nvPr/>
+        </p:nvSpPr>
+        <p:spPr>
+          <a:xfrm>
+            <a:off x="365760" y="1554480"/>
+            <a:ext cx="4069080" cy="3291840"/>
+          </a:xfrm>
+          <a:prstGeom prst="rect">
+            <a:avLst/>
+          </a:prstGeom>
+          <a:noFill/>
+          <a:ln/>
+        </p:spPr>
+        <p:txBody>
+          <a:bodyPr wrap="square" rtlCol="0" anchor="ctr"/>
+          <a:lstStyle/>
+          <a:p>
+            <a:pPr marL="342900" indent="-342900">
+              <a:spcAft>
+                <a:spcPts val="600"/>
+              </a:spcAft>
+              <a:buSzPct val="100000"/>
+              <a:buChar char="•"/>
+            </a:pPr>
+            <a:r>
+              <a:rPr lang="en-US" sz="1500" dirty="0">
                 <a:solidFill>
                   <a:srgbClr val="212121"/>
                 </a:solidFill>
-                <a:latin typeface="Consolas" pitchFamily="34" charset="0"/>
-                <a:ea typeface="Consolas" pitchFamily="34" charset="-122"/>
-                <a:cs typeface="Consolas" pitchFamily="34" charset="-120"/>
-              </a:rPr>
-              <a:t>https://&lt;project-name&gt;.services.ai.azure.com</a:t>
-            </a:r>
-            <a:endParaRPr lang="en-US" sz="1800" dirty="0"/>
+                <a:latin typeface="Calibri" pitchFamily="34" charset="0"/>
+                <a:ea typeface="Calibri" pitchFamily="34" charset="-122"/>
+                <a:cs typeface="Calibri" pitchFamily="34" charset="-120"/>
+              </a:rPr>
+              <a:t>Model deployments</a:t>
+            </a:r>
+            <a:endParaRPr lang="en-US" sz="1500" dirty="0"/>
+          </a:p>
+          <a:p>
+            <a:pPr marL="342900" indent="-342900">
+              <a:spcAft>
+                <a:spcPts val="600"/>
+              </a:spcAft>
+              <a:buSzPct val="100000"/>
+              <a:buChar char="•"/>
+            </a:pPr>
+            <a:r>
+              <a:rPr lang="en-US" sz="1500" dirty="0">
+                <a:solidFill>
+                  <a:srgbClr val="212121"/>
+                </a:solidFill>
+                <a:latin typeface="Calibri" pitchFamily="34" charset="0"/>
+                <a:ea typeface="Calibri" pitchFamily="34" charset="-122"/>
+                <a:cs typeface="Calibri" pitchFamily="34" charset="-120"/>
+              </a:rPr>
+              <a:t>Security &amp; networking</a:t>
+            </a:r>
+            <a:endParaRPr lang="en-US" sz="1500" dirty="0"/>
+          </a:p>
+          <a:p>
+            <a:pPr marL="342900" indent="-342900">
+              <a:spcAft>
+                <a:spcPts val="600"/>
+              </a:spcAft>
+              <a:buSzPct val="100000"/>
+              <a:buChar char="•"/>
+            </a:pPr>
+            <a:r>
+              <a:rPr lang="en-US" sz="1500" dirty="0">
+                <a:solidFill>
+                  <a:srgbClr val="212121"/>
+                </a:solidFill>
+                <a:latin typeface="Calibri" pitchFamily="34" charset="0"/>
+                <a:ea typeface="Calibri" pitchFamily="34" charset="-122"/>
+                <a:cs typeface="Calibri" pitchFamily="34" charset="-120"/>
+              </a:rPr>
+              <a:t>Connections to connected resources</a:t>
+            </a:r>
+            <a:endParaRPr lang="en-US" sz="1500" dirty="0"/>
+          </a:p>
+          <a:p>
+            <a:pPr marL="342900" indent="-342900">
+              <a:spcAft>
+                <a:spcPts val="600"/>
+              </a:spcAft>
+              <a:buSzPct val="100000"/>
+              <a:buChar char="•"/>
+            </a:pPr>
+            <a:r>
+              <a:rPr lang="en-US" sz="1500" dirty="0">
+                <a:solidFill>
+                  <a:srgbClr val="212121"/>
+                </a:solidFill>
+                <a:latin typeface="Calibri" pitchFamily="34" charset="0"/>
+                <a:ea typeface="Calibri" pitchFamily="34" charset="-122"/>
+                <a:cs typeface="Calibri" pitchFamily="34" charset="-120"/>
+              </a:rPr>
+              <a:t>Resource-scoped RBAC roles (Foundry User, Foundry Owner)</a:t>
+            </a:r>
+            <a:endParaRPr lang="en-US" sz="1500" dirty="0"/>
           </a:p>
         </p:txBody>
       </p:sp>
@@ -5145,8 +5991,8 @@
         </p:nvSpPr>
         <p:spPr>
           <a:xfrm>
-            <a:off x="365760" y="2194560"/>
-            <a:ext cx="8412480" cy="1371600"/>
+            <a:off x="4709160" y="1554480"/>
+            <a:ext cx="4069080" cy="3291840"/>
           </a:xfrm>
           <a:prstGeom prst="rect">
             <a:avLst/>
@@ -5156,23 +6002,191 @@
         </p:spPr>
         <p:txBody>
           <a:bodyPr wrap="square" rtlCol="0" anchor="ctr"/>
+          <a:lstStyle/>
+          <a:p>
+            <a:pPr marL="342900" indent="-342900">
+              <a:spcAft>
+                <a:spcPts val="600"/>
+              </a:spcAft>
+              <a:buSzPct val="100000"/>
+              <a:buChar char="•"/>
+            </a:pPr>
+            <a:r>
+              <a:rPr lang="en-US" sz="1500" dirty="0">
+                <a:solidFill>
+                  <a:srgbClr val="212121"/>
+                </a:solidFill>
+                <a:latin typeface="Calibri" pitchFamily="34" charset="0"/>
+                <a:ea typeface="Calibri" pitchFamily="34" charset="-122"/>
+                <a:cs typeface="Calibri" pitchFamily="34" charset="-120"/>
+              </a:rPr>
+              <a:t>Agents (Prompt agents, Hosted agents)</a:t>
+            </a:r>
+            <a:endParaRPr lang="en-US" sz="1500" dirty="0"/>
+          </a:p>
+          <a:p>
+            <a:pPr marL="342900" indent="-342900">
+              <a:spcAft>
+                <a:spcPts val="600"/>
+              </a:spcAft>
+              <a:buSzPct val="100000"/>
+              <a:buChar char="•"/>
+            </a:pPr>
+            <a:r>
+              <a:rPr lang="en-US" sz="1500" dirty="0">
+                <a:solidFill>
+                  <a:srgbClr val="212121"/>
+                </a:solidFill>
+                <a:latin typeface="Calibri" pitchFamily="34" charset="0"/>
+                <a:ea typeface="Calibri" pitchFamily="34" charset="-122"/>
+                <a:cs typeface="Calibri" pitchFamily="34" charset="-120"/>
+              </a:rPr>
+              <a:t>Files</a:t>
+            </a:r>
+            <a:endParaRPr lang="en-US" sz="1500" dirty="0"/>
+          </a:p>
+          <a:p>
+            <a:pPr marL="342900" indent="-342900">
+              <a:spcAft>
+                <a:spcPts val="600"/>
+              </a:spcAft>
+              <a:buSzPct val="100000"/>
+              <a:buChar char="•"/>
+            </a:pPr>
+            <a:r>
+              <a:rPr lang="en-US" sz="1500" dirty="0">
+                <a:solidFill>
+                  <a:srgbClr val="212121"/>
+                </a:solidFill>
+                <a:latin typeface="Calibri" pitchFamily="34" charset="0"/>
+                <a:ea typeface="Calibri" pitchFamily="34" charset="-122"/>
+                <a:cs typeface="Calibri" pitchFamily="34" charset="-120"/>
+              </a:rPr>
+              <a:t>Evaluations</a:t>
+            </a:r>
+            <a:endParaRPr lang="en-US" sz="1500" dirty="0"/>
+          </a:p>
+          <a:p>
+            <a:pPr marL="342900" indent="-342900">
+              <a:spcAft>
+                <a:spcPts val="600"/>
+              </a:spcAft>
+              <a:buSzPct val="100000"/>
+              <a:buChar char="•"/>
+            </a:pPr>
+            <a:r>
+              <a:rPr lang="en-US" sz="1500" dirty="0">
+                <a:solidFill>
+                  <a:srgbClr val="212121"/>
+                </a:solidFill>
+                <a:latin typeface="Calibri" pitchFamily="34" charset="0"/>
+                <a:ea typeface="Calibri" pitchFamily="34" charset="-122"/>
+                <a:cs typeface="Calibri" pitchFamily="34" charset="-120"/>
+              </a:rPr>
+              <a:t>Project-scoped RBAC assignments</a:t>
+            </a:r>
+            <a:endParaRPr lang="en-US" sz="1500" dirty="0"/>
+          </a:p>
+        </p:txBody>
+      </p:sp>
+      <p:sp>
+        <p:nvSpPr>
+          <p:cNvPr id="9" name="Shape 7"/>
+          <p:cNvSpPr/>
+          <p:nvPr/>
+        </p:nvSpPr>
+        <p:spPr>
+          <a:xfrm>
+            <a:off x="365760" y="4160520"/>
+            <a:ext cx="8412480" cy="548640"/>
+          </a:xfrm>
+          <a:prstGeom prst="rect">
+            <a:avLst/>
+          </a:prstGeom>
+          <a:solidFill>
+            <a:srgbClr val="CADCFC"/>
+          </a:solidFill>
+          <a:ln/>
+        </p:spPr>
+      </p:sp>
+      <p:sp>
+        <p:nvSpPr>
+          <p:cNvPr id="10" name="Text 8"/>
+          <p:cNvSpPr/>
+          <p:nvPr/>
+        </p:nvSpPr>
+        <p:spPr>
+          <a:xfrm>
+            <a:off x="502920" y="4206240"/>
+            <a:ext cx="8138160" cy="457200"/>
+          </a:xfrm>
+          <a:prstGeom prst="rect">
+            <a:avLst/>
+          </a:prstGeom>
+          <a:noFill/>
+          <a:ln/>
+        </p:spPr>
+        <p:txBody>
+          <a:bodyPr wrap="square" lIns="0" tIns="0" rIns="0" bIns="0" rtlCol="0" anchor="ctr"/>
           <a:lstStyle/>
           <a:p>
             <a:pPr indent="0" marL="0">
               <a:buNone/>
             </a:pPr>
             <a:r>
-              <a:rPr lang="en-US" sz="1500" dirty="0">
-                <a:solidFill>
-                  <a:srgbClr val="212121"/>
-                </a:solidFill>
-                <a:latin typeface="Calibri" pitchFamily="34" charset="0"/>
-                <a:ea typeface="Calibri" pitchFamily="34" charset="-122"/>
-                <a:cs typeface="Calibri" pitchFamily="34" charset="-120"/>
-              </a:rPr>
-              <a:t>Set this as FOUNDRY_PROJECT_ENDPOINT in every lab's .env. MAF connects with this endpoint plus a credential — AzureCliCredential in dev, managed identity in production.</a:t>
-            </a:r>
-            <a:endParaRPr lang="en-US" sz="1500" dirty="0"/>
+              <a:rPr lang="en-US" sz="1200" b="1" dirty="0">
+                <a:solidFill>
+                  <a:srgbClr val="1E2761"/>
+                </a:solidFill>
+                <a:latin typeface="Calibri" pitchFamily="34" charset="0"/>
+                <a:ea typeface="Calibri" pitchFamily="34" charset="-122"/>
+                <a:cs typeface="Calibri" pitchFamily="34" charset="-120"/>
+              </a:rPr>
+              <a:t>Starter RBAC: </a:t>
+            </a:r>
+            <a:pPr indent="0" marL="0">
+              <a:buNone/>
+            </a:pPr>
+            <a:r>
+              <a:rPr lang="en-US" sz="1200" dirty="0">
+                <a:solidFill>
+                  <a:srgbClr val="1E2761"/>
+                </a:solidFill>
+                <a:latin typeface="Calibri" pitchFamily="34" charset="0"/>
+                <a:ea typeface="Calibri" pitchFamily="34" charset="-122"/>
+                <a:cs typeface="Calibri" pitchFamily="34" charset="-120"/>
+              </a:rPr>
+              <a:t>assign every developer </a:t>
+            </a:r>
+            <a:pPr indent="0" marL="0">
+              <a:buNone/>
+            </a:pPr>
+            <a:r>
+              <a:rPr lang="en-US" sz="1200" b="1" dirty="0">
+                <a:solidFill>
+                  <a:srgbClr val="1E2761"/>
+                </a:solidFill>
+                <a:latin typeface="Calibri" pitchFamily="34" charset="0"/>
+                <a:ea typeface="Calibri" pitchFamily="34" charset="-122"/>
+                <a:cs typeface="Calibri" pitchFamily="34" charset="-120"/>
+              </a:rPr>
+              <a:t>Foundry User</a:t>
+            </a:r>
+            <a:pPr indent="0" marL="0">
+              <a:buNone/>
+            </a:pPr>
+            <a:r>
+              <a:rPr lang="en-US" sz="1200" dirty="0">
+                <a:solidFill>
+                  <a:srgbClr val="1E2761"/>
+                </a:solidFill>
+                <a:latin typeface="Calibri" pitchFamily="34" charset="0"/>
+                <a:ea typeface="Calibri" pitchFamily="34" charset="-122"/>
+                <a:cs typeface="Calibri" pitchFamily="34" charset="-120"/>
+              </a:rPr>
+              <a:t> at the Foundry resource scope. That covers Day 1 lab access. Fine-grained project-scoped roles come later.</a:t>
+            </a:r>
+            <a:endParaRPr lang="en-US" sz="1200" dirty="0"/>
           </a:p>
         </p:txBody>
       </p:sp>
@@ -5300,7 +6314,7 @@
                 <a:ea typeface="Calibri" pitchFamily="34" charset="-122"/>
                 <a:cs typeface="Calibri" pitchFamily="34" charset="-120"/>
               </a:rPr>
-              <a:t>Model catalog</a:t>
+              <a:t>Project endpoints</a:t>
             </a:r>
             <a:endParaRPr lang="en-US" sz="2800" dirty="0"/>
           </a:p>
@@ -5314,8 +6328,8 @@
         </p:nvSpPr>
         <p:spPr>
           <a:xfrm>
-            <a:off x="365760" y="1097280"/>
-            <a:ext cx="8412480" cy="3749040"/>
+            <a:off x="365760" y="1051560"/>
+            <a:ext cx="8412480" cy="365760"/>
           </a:xfrm>
           <a:prstGeom prst="rect">
             <a:avLst/>
@@ -5327,12 +6341,8 @@
           <a:bodyPr wrap="square" rtlCol="0" anchor="ctr"/>
           <a:lstStyle/>
           <a:p>
-            <a:pPr marL="342900" indent="-342900">
-              <a:spcAft>
-                <a:spcPts val="600"/>
-              </a:spcAft>
-              <a:buSzPct val="100000"/>
-              <a:buChar char="•"/>
+            <a:pPr indent="0" marL="0">
+              <a:buNone/>
             </a:pPr>
             <a:r>
               <a:rPr lang="en-US" sz="1500" dirty="0">
@@ -5343,17 +6353,99 @@
                 <a:ea typeface="Calibri" pitchFamily="34" charset="-122"/>
                 <a:cs typeface="Calibri" pitchFamily="34" charset="-120"/>
               </a:rPr>
-              <a:t>Browse frontier models (OpenAI, Meta, Mistral, others by region)</a:t>
+              <a:t>Every Foundry project has an endpoint like:</a:t>
             </a:r>
             <a:endParaRPr lang="en-US" sz="1500" dirty="0"/>
           </a:p>
-          <a:p>
-            <a:pPr marL="342900" indent="-342900">
-              <a:spcAft>
-                <a:spcPts val="600"/>
-              </a:spcAft>
-              <a:buSzPct val="100000"/>
-              <a:buChar char="•"/>
+        </p:txBody>
+      </p:sp>
+      <p:sp>
+        <p:nvSpPr>
+          <p:cNvPr id="6" name="Shape 4"/>
+          <p:cNvSpPr/>
+          <p:nvPr/>
+        </p:nvSpPr>
+        <p:spPr>
+          <a:xfrm>
+            <a:off x="365760" y="1417320"/>
+            <a:ext cx="8412480" cy="548640"/>
+          </a:xfrm>
+          <a:prstGeom prst="rect">
+            <a:avLst/>
+          </a:prstGeom>
+          <a:solidFill>
+            <a:srgbClr val="F3F4F6"/>
+          </a:solidFill>
+          <a:ln w="6350">
+            <a:solidFill>
+              <a:srgbClr val="D1D5DB"/>
+            </a:solidFill>
+            <a:prstDash val="solid"/>
+          </a:ln>
+        </p:spPr>
+      </p:sp>
+      <p:sp>
+        <p:nvSpPr>
+          <p:cNvPr id="7" name="Text 5"/>
+          <p:cNvSpPr/>
+          <p:nvPr/>
+        </p:nvSpPr>
+        <p:spPr>
+          <a:xfrm>
+            <a:off x="502920" y="1508760"/>
+            <a:ext cx="8138160" cy="365760"/>
+          </a:xfrm>
+          <a:prstGeom prst="rect">
+            <a:avLst/>
+          </a:prstGeom>
+          <a:noFill/>
+          <a:ln/>
+        </p:spPr>
+        <p:txBody>
+          <a:bodyPr wrap="square" lIns="0" tIns="0" rIns="0" bIns="0" rtlCol="0" anchor="t"/>
+          <a:lstStyle/>
+          <a:p>
+            <a:pPr indent="0" marL="0">
+              <a:buNone/>
+            </a:pPr>
+            <a:r>
+              <a:rPr lang="en-US" sz="1800" dirty="0">
+                <a:solidFill>
+                  <a:srgbClr val="212121"/>
+                </a:solidFill>
+                <a:latin typeface="Consolas" pitchFamily="34" charset="0"/>
+                <a:ea typeface="Consolas" pitchFamily="34" charset="-122"/>
+                <a:cs typeface="Consolas" pitchFamily="34" charset="-120"/>
+              </a:rPr>
+              <a:t>https://&lt;project-name&gt;.services.ai.azure.com</a:t>
+            </a:r>
+            <a:endParaRPr lang="en-US" sz="1800" dirty="0"/>
+          </a:p>
+        </p:txBody>
+      </p:sp>
+      <p:sp>
+        <p:nvSpPr>
+          <p:cNvPr id="8" name="Text 6"/>
+          <p:cNvSpPr/>
+          <p:nvPr/>
+        </p:nvSpPr>
+        <p:spPr>
+          <a:xfrm>
+            <a:off x="365760" y="2194560"/>
+            <a:ext cx="8412480" cy="1371600"/>
+          </a:xfrm>
+          <a:prstGeom prst="rect">
+            <a:avLst/>
+          </a:prstGeom>
+          <a:noFill/>
+          <a:ln/>
+        </p:spPr>
+        <p:txBody>
+          <a:bodyPr wrap="square" rtlCol="0" anchor="ctr"/>
+          <a:lstStyle/>
+          <a:p>
+            <a:pPr indent="0" marL="0">
+              <a:buNone/>
             </a:pPr>
             <a:r>
               <a:rPr lang="en-US" sz="1500" dirty="0">
@@ -5364,49 +6456,7 @@
                 <a:ea typeface="Calibri" pitchFamily="34" charset="-122"/>
                 <a:cs typeface="Calibri" pitchFamily="34" charset="-120"/>
               </a:rPr>
-              <a:t>Filter by capability — chat, embeddings, vision, etc.</a:t>
-            </a:r>
-            <a:endParaRPr lang="en-US" sz="1500" dirty="0"/>
-          </a:p>
-          <a:p>
-            <a:pPr marL="342900" indent="-342900">
-              <a:spcAft>
-                <a:spcPts val="600"/>
-              </a:spcAft>
-              <a:buSzPct val="100000"/>
-              <a:buChar char="•"/>
-            </a:pPr>
-            <a:r>
-              <a:rPr lang="en-US" sz="1500" dirty="0">
-                <a:solidFill>
-                  <a:srgbClr val="212121"/>
-                </a:solidFill>
-                <a:latin typeface="Calibri" pitchFamily="34" charset="0"/>
-                <a:ea typeface="Calibri" pitchFamily="34" charset="-122"/>
-                <a:cs typeface="Calibri" pitchFamily="34" charset="-120"/>
-              </a:rPr>
-              <a:t>See region availability, pricing tier, context window</a:t>
-            </a:r>
-            <a:endParaRPr lang="en-US" sz="1500" dirty="0"/>
-          </a:p>
-          <a:p>
-            <a:pPr marL="342900" indent="-342900">
-              <a:spcAft>
-                <a:spcPts val="600"/>
-              </a:spcAft>
-              <a:buSzPct val="100000"/>
-              <a:buChar char="•"/>
-            </a:pPr>
-            <a:r>
-              <a:rPr lang="en-US" sz="1500" dirty="0">
-                <a:solidFill>
-                  <a:srgbClr val="212121"/>
-                </a:solidFill>
-                <a:latin typeface="Calibri" pitchFamily="34" charset="0"/>
-                <a:ea typeface="Calibri" pitchFamily="34" charset="-122"/>
-                <a:cs typeface="Calibri" pitchFamily="34" charset="-120"/>
-              </a:rPr>
-              <a:t>Not every model is available in every region — check region and quota first</a:t>
+              <a:t>Set this as FOUNDRY_PROJECT_ENDPOINT in every lab's .env. MAF connects with this endpoint plus a credential — AzureCliCredential in dev, managed identity in production.</a:t>
             </a:r>
             <a:endParaRPr lang="en-US" sz="1500" dirty="0"/>
           </a:p>
@@ -5536,7 +6586,7 @@
                 <a:ea typeface="Calibri" pitchFamily="34" charset="-122"/>
                 <a:cs typeface="Calibri" pitchFamily="34" charset="-120"/>
               </a:rPr>
-              <a:t>Model deployments</a:t>
+              <a:t>Model catalog</a:t>
             </a:r>
             <a:endParaRPr lang="en-US" sz="2800" dirty="0"/>
           </a:p>
@@ -5571,7 +6621,7 @@
               <a:buChar char="•"/>
             </a:pPr>
             <a:r>
-              <a:rPr lang="en-US" sz="1400" dirty="0">
+              <a:rPr lang="en-US" sz="1500" dirty="0">
                 <a:solidFill>
                   <a:srgbClr val="212121"/>
                 </a:solidFill>
@@ -5579,9 +6629,9 @@
                 <a:ea typeface="Calibri" pitchFamily="34" charset="-122"/>
                 <a:cs typeface="Calibri" pitchFamily="34" charset="-120"/>
               </a:rPr>
-              <a:t>A deployment is a named, callable instance of a specific model</a:t>
-            </a:r>
-            <a:endParaRPr lang="en-US" sz="1400" dirty="0"/>
+              <a:t>Browse frontier models (OpenAI, Meta, Mistral, others by region)</a:t>
+            </a:r>
+            <a:endParaRPr lang="en-US" sz="1500" dirty="0"/>
           </a:p>
           <a:p>
             <a:pPr marL="342900" indent="-342900">
@@ -5592,7 +6642,7 @@
               <a:buChar char="•"/>
             </a:pPr>
             <a:r>
-              <a:rPr lang="en-US" sz="1400" dirty="0">
+              <a:rPr lang="en-US" sz="1500" dirty="0">
                 <a:solidFill>
                   <a:srgbClr val="212121"/>
                 </a:solidFill>
@@ -5600,93 +6650,9 @@
                 <a:ea typeface="Calibri" pitchFamily="34" charset="-122"/>
                 <a:cs typeface="Calibri" pitchFamily="34" charset="-120"/>
               </a:rPr>
-              <a:t>Each deployment has:</a:t>
-            </a:r>
-            <a:endParaRPr lang="en-US" sz="1400" dirty="0"/>
-          </a:p>
-          <a:p>
-            <a:pPr lvl="1" marL="685800" indent="-342900">
-              <a:spcAft>
-                <a:spcPts val="600"/>
-              </a:spcAft>
-              <a:buSzPct val="100000"/>
-              <a:buChar char="•"/>
-            </a:pPr>
-            <a:r>
-              <a:rPr lang="en-US" sz="1400" dirty="0">
-                <a:solidFill>
-                  <a:srgbClr val="212121"/>
-                </a:solidFill>
-                <a:latin typeface="Calibri" pitchFamily="34" charset="0"/>
-                <a:ea typeface="Calibri" pitchFamily="34" charset="-122"/>
-                <a:cs typeface="Calibri" pitchFamily="34" charset="-120"/>
-              </a:rPr>
-              <a:t>Deployment name — what you pass to MAF as model=…</a:t>
-            </a:r>
-            <a:endParaRPr lang="en-US" sz="1400" dirty="0"/>
-          </a:p>
-          <a:p>
-            <a:pPr lvl="1" marL="685800" indent="-342900">
-              <a:spcAft>
-                <a:spcPts val="600"/>
-              </a:spcAft>
-              <a:buSzPct val="100000"/>
-              <a:buChar char="•"/>
-            </a:pPr>
-            <a:r>
-              <a:rPr lang="en-US" sz="1400" dirty="0">
-                <a:solidFill>
-                  <a:srgbClr val="212121"/>
-                </a:solidFill>
-                <a:latin typeface="Calibri" pitchFamily="34" charset="0"/>
-                <a:ea typeface="Calibri" pitchFamily="34" charset="-122"/>
-                <a:cs typeface="Calibri" pitchFamily="34" charset="-120"/>
-              </a:rPr>
-              <a:t>Model version</a:t>
-            </a:r>
-            <a:endParaRPr lang="en-US" sz="1400" dirty="0"/>
-          </a:p>
-          <a:p>
-            <a:pPr lvl="1" marL="685800" indent="-342900">
-              <a:spcAft>
-                <a:spcPts val="600"/>
-              </a:spcAft>
-              <a:buSzPct val="100000"/>
-              <a:buChar char="•"/>
-            </a:pPr>
-            <a:r>
-              <a:rPr lang="en-US" sz="1400" dirty="0">
-                <a:solidFill>
-                  <a:srgbClr val="212121"/>
-                </a:solidFill>
-                <a:latin typeface="Calibri" pitchFamily="34" charset="0"/>
-                <a:ea typeface="Calibri" pitchFamily="34" charset="-122"/>
-                <a:cs typeface="Calibri" pitchFamily="34" charset="-120"/>
-              </a:rPr>
-              <a:t>Capacity — tokens per minute</a:t>
-            </a:r>
-            <a:endParaRPr lang="en-US" sz="1400" dirty="0"/>
-          </a:p>
-          <a:p>
-            <a:pPr lvl="1" marL="685800" indent="-342900">
-              <a:spcAft>
-                <a:spcPts val="600"/>
-              </a:spcAft>
-              <a:buSzPct val="100000"/>
-              <a:buChar char="•"/>
-            </a:pPr>
-            <a:r>
-              <a:rPr lang="en-US" sz="1400" dirty="0">
-                <a:solidFill>
-                  <a:srgbClr val="212121"/>
-                </a:solidFill>
-                <a:latin typeface="Calibri" pitchFamily="34" charset="0"/>
-                <a:ea typeface="Calibri" pitchFamily="34" charset="-122"/>
-                <a:cs typeface="Calibri" pitchFamily="34" charset="-120"/>
-              </a:rPr>
-              <a:t>Region — inherited from the project</a:t>
-            </a:r>
-            <a:endParaRPr lang="en-US" sz="1400" dirty="0"/>
+              <a:t>Filter by capability — chat, embeddings, vision, etc.</a:t>
+            </a:r>
+            <a:endParaRPr lang="en-US" sz="1500" dirty="0"/>
           </a:p>
           <a:p>
             <a:pPr marL="342900" indent="-342900">
@@ -5697,7 +6663,7 @@
               <a:buChar char="•"/>
             </a:pPr>
             <a:r>
-              <a:rPr lang="en-US" sz="1400" dirty="0">
+              <a:rPr lang="en-US" sz="1500" dirty="0">
                 <a:solidFill>
                   <a:srgbClr val="212121"/>
                 </a:solidFill>
@@ -5705,9 +6671,30 @@
                 <a:ea typeface="Calibri" pitchFamily="34" charset="-122"/>
                 <a:cs typeface="Calibri" pitchFamily="34" charset="-120"/>
               </a:rPr>
-              <a:t>Rule of thumb: one deployment per (model, role) pair. Don't share prod and dev.</a:t>
-            </a:r>
-            <a:endParaRPr lang="en-US" sz="1400" dirty="0"/>
+              <a:t>See region availability, pricing tier, context window</a:t>
+            </a:r>
+            <a:endParaRPr lang="en-US" sz="1500" dirty="0"/>
+          </a:p>
+          <a:p>
+            <a:pPr marL="342900" indent="-342900">
+              <a:spcAft>
+                <a:spcPts val="600"/>
+              </a:spcAft>
+              <a:buSzPct val="100000"/>
+              <a:buChar char="•"/>
+            </a:pPr>
+            <a:r>
+              <a:rPr lang="en-US" sz="1500" dirty="0">
+                <a:solidFill>
+                  <a:srgbClr val="212121"/>
+                </a:solidFill>
+                <a:latin typeface="Calibri" pitchFamily="34" charset="0"/>
+                <a:ea typeface="Calibri" pitchFamily="34" charset="-122"/>
+                <a:cs typeface="Calibri" pitchFamily="34" charset="-120"/>
+              </a:rPr>
+              <a:t>Not every model is available in every region — check region and quota first</a:t>
+            </a:r>
+            <a:endParaRPr lang="en-US" sz="1500" dirty="0"/>
           </a:p>
         </p:txBody>
       </p:sp>
@@ -5835,7 +6822,7 @@
                 <a:ea typeface="Calibri" pitchFamily="34" charset="-122"/>
                 <a:cs typeface="Calibri" pitchFamily="34" charset="-120"/>
               </a:rPr>
-              <a:t>Playgrounds</a:t>
+              <a:t>Model deployments</a:t>
             </a:r>
             <a:endParaRPr lang="en-US" sz="2800" dirty="0"/>
           </a:p>
@@ -5870,7 +6857,7 @@
               <a:buChar char="•"/>
             </a:pPr>
             <a:r>
-              <a:rPr lang="en-US" sz="1500" dirty="0">
+              <a:rPr lang="en-US" sz="1400" dirty="0">
                 <a:solidFill>
                   <a:srgbClr val="212121"/>
                 </a:solidFill>
@@ -5878,9 +6865,9 @@
                 <a:ea typeface="Calibri" pitchFamily="34" charset="-122"/>
                 <a:cs typeface="Calibri" pitchFamily="34" charset="-120"/>
               </a:rPr>
-              <a:t>Chat playground — test a deployed model interactively</a:t>
-            </a:r>
-            <a:endParaRPr lang="en-US" sz="1500" dirty="0"/>
+              <a:t>A deployment is a named, callable instance of a specific model</a:t>
+            </a:r>
+            <a:endParaRPr lang="en-US" sz="1400" dirty="0"/>
           </a:p>
           <a:p>
             <a:pPr marL="342900" indent="-342900">
@@ -5891,7 +6878,7 @@
               <a:buChar char="•"/>
             </a:pPr>
             <a:r>
-              <a:rPr lang="en-US" sz="1500" dirty="0">
+              <a:rPr lang="en-US" sz="1400" dirty="0">
                 <a:solidFill>
                   <a:srgbClr val="212121"/>
                 </a:solidFill>
@@ -5899,9 +6886,93 @@
                 <a:ea typeface="Calibri" pitchFamily="34" charset="-122"/>
                 <a:cs typeface="Calibri" pitchFamily="34" charset="-120"/>
               </a:rPr>
-              <a:t>Agent playground — test a Prompt agent or Hosted agent you've created in Foundry</a:t>
-            </a:r>
-            <a:endParaRPr lang="en-US" sz="1500" dirty="0"/>
+              <a:t>Each deployment has:</a:t>
+            </a:r>
+            <a:endParaRPr lang="en-US" sz="1400" dirty="0"/>
+          </a:p>
+          <a:p>
+            <a:pPr lvl="1" marL="685800" indent="-342900">
+              <a:spcAft>
+                <a:spcPts val="600"/>
+              </a:spcAft>
+              <a:buSzPct val="100000"/>
+              <a:buChar char="•"/>
+            </a:pPr>
+            <a:r>
+              <a:rPr lang="en-US" sz="1400" dirty="0">
+                <a:solidFill>
+                  <a:srgbClr val="212121"/>
+                </a:solidFill>
+                <a:latin typeface="Calibri" pitchFamily="34" charset="0"/>
+                <a:ea typeface="Calibri" pitchFamily="34" charset="-122"/>
+                <a:cs typeface="Calibri" pitchFamily="34" charset="-120"/>
+              </a:rPr>
+              <a:t>Deployment name — what you pass to MAF as model=…</a:t>
+            </a:r>
+            <a:endParaRPr lang="en-US" sz="1400" dirty="0"/>
+          </a:p>
+          <a:p>
+            <a:pPr lvl="1" marL="685800" indent="-342900">
+              <a:spcAft>
+                <a:spcPts val="600"/>
+              </a:spcAft>
+              <a:buSzPct val="100000"/>
+              <a:buChar char="•"/>
+            </a:pPr>
+            <a:r>
+              <a:rPr lang="en-US" sz="1400" dirty="0">
+                <a:solidFill>
+                  <a:srgbClr val="212121"/>
+                </a:solidFill>
+                <a:latin typeface="Calibri" pitchFamily="34" charset="0"/>
+                <a:ea typeface="Calibri" pitchFamily="34" charset="-122"/>
+                <a:cs typeface="Calibri" pitchFamily="34" charset="-120"/>
+              </a:rPr>
+              <a:t>Model version</a:t>
+            </a:r>
+            <a:endParaRPr lang="en-US" sz="1400" dirty="0"/>
+          </a:p>
+          <a:p>
+            <a:pPr lvl="1" marL="685800" indent="-342900">
+              <a:spcAft>
+                <a:spcPts val="600"/>
+              </a:spcAft>
+              <a:buSzPct val="100000"/>
+              <a:buChar char="•"/>
+            </a:pPr>
+            <a:r>
+              <a:rPr lang="en-US" sz="1400" dirty="0">
+                <a:solidFill>
+                  <a:srgbClr val="212121"/>
+                </a:solidFill>
+                <a:latin typeface="Calibri" pitchFamily="34" charset="0"/>
+                <a:ea typeface="Calibri" pitchFamily="34" charset="-122"/>
+                <a:cs typeface="Calibri" pitchFamily="34" charset="-120"/>
+              </a:rPr>
+              <a:t>Capacity — tokens per minute</a:t>
+            </a:r>
+            <a:endParaRPr lang="en-US" sz="1400" dirty="0"/>
+          </a:p>
+          <a:p>
+            <a:pPr lvl="1" marL="685800" indent="-342900">
+              <a:spcAft>
+                <a:spcPts val="600"/>
+              </a:spcAft>
+              <a:buSzPct val="100000"/>
+              <a:buChar char="•"/>
+            </a:pPr>
+            <a:r>
+              <a:rPr lang="en-US" sz="1400" dirty="0">
+                <a:solidFill>
+                  <a:srgbClr val="212121"/>
+                </a:solidFill>
+                <a:latin typeface="Calibri" pitchFamily="34" charset="0"/>
+                <a:ea typeface="Calibri" pitchFamily="34" charset="-122"/>
+                <a:cs typeface="Calibri" pitchFamily="34" charset="-120"/>
+              </a:rPr>
+              <a:t>Region — inherited from the project</a:t>
+            </a:r>
+            <a:endParaRPr lang="en-US" sz="1400" dirty="0"/>
           </a:p>
           <a:p>
             <a:pPr marL="342900" indent="-342900">
@@ -5912,7 +6983,7 @@
               <a:buChar char="•"/>
             </a:pPr>
             <a:r>
-              <a:rPr lang="en-US" sz="1500" dirty="0">
+              <a:rPr lang="en-US" sz="1400" dirty="0">
                 <a:solidFill>
                   <a:srgbClr val="212121"/>
                 </a:solidFill>
@@ -5920,51 +6991,9 @@
                 <a:ea typeface="Calibri" pitchFamily="34" charset="-122"/>
                 <a:cs typeface="Calibri" pitchFamily="34" charset="-120"/>
               </a:rPr>
-              <a:t>Prompt flow / evaluation playgrounds — for testing eval configurations</a:t>
-            </a:r>
-            <a:endParaRPr lang="en-US" sz="1500" dirty="0"/>
-          </a:p>
-          <a:p>
-            <a:pPr marL="342900" indent="-342900">
-              <a:spcAft>
-                <a:spcPts val="600"/>
-              </a:spcAft>
-              <a:buSzPct val="100000"/>
-              <a:buChar char="•"/>
-            </a:pPr>
-            <a:r>
-              <a:rPr lang="en-US" sz="1500" dirty="0">
-                <a:solidFill>
-                  <a:srgbClr val="212121"/>
-                </a:solidFill>
-                <a:latin typeface="Calibri" pitchFamily="34" charset="0"/>
-                <a:ea typeface="Calibri" pitchFamily="34" charset="-122"/>
-                <a:cs typeface="Calibri" pitchFamily="34" charset="-120"/>
-              </a:rPr>
-              <a:t>Use playgrounds to sanity-check before writing agent code</a:t>
-            </a:r>
-            <a:endParaRPr lang="en-US" sz="1500" dirty="0"/>
-          </a:p>
-          <a:p>
-            <a:pPr marL="342900" indent="-342900">
-              <a:spcAft>
-                <a:spcPts val="600"/>
-              </a:spcAft>
-              <a:buSzPct val="100000"/>
-              <a:buChar char="•"/>
-            </a:pPr>
-            <a:r>
-              <a:rPr lang="en-US" sz="1500" dirty="0">
-                <a:solidFill>
-                  <a:srgbClr val="212121"/>
-                </a:solidFill>
-                <a:latin typeface="Calibri" pitchFamily="34" charset="0"/>
-                <a:ea typeface="Calibri" pitchFamily="34" charset="-122"/>
-                <a:cs typeface="Calibri" pitchFamily="34" charset="-120"/>
-              </a:rPr>
-              <a:t>If it doesn't work in the playground, it won't work in MAF either</a:t>
-            </a:r>
-            <a:endParaRPr lang="en-US" sz="1500" dirty="0"/>
+              <a:t>Rule of thumb: one deployment per (model, role) pair. Don't share prod and dev.</a:t>
+            </a:r>
+            <a:endParaRPr lang="en-US" sz="1400" dirty="0"/>
           </a:p>
         </p:txBody>
       </p:sp>
@@ -6092,7 +7121,7 @@
                 <a:ea typeface="Calibri" pitchFamily="34" charset="-122"/>
                 <a:cs typeface="Calibri" pitchFamily="34" charset="-120"/>
               </a:rPr>
-              <a:t>Connections</a:t>
+              <a:t>Playgrounds</a:t>
             </a:r>
             <a:endParaRPr lang="en-US" sz="2800" dirty="0"/>
           </a:p>
@@ -6135,7 +7164,7 @@
                 <a:ea typeface="Calibri" pitchFamily="34" charset="-122"/>
                 <a:cs typeface="Calibri" pitchFamily="34" charset="-120"/>
               </a:rPr>
-              <a:t>Connections are how a Foundry project reaches other Azure resources — AI Search, storage, Fabric, and more</a:t>
+              <a:t>Chat playground — test a deployed model interactively</a:t>
             </a:r>
             <a:endParaRPr lang="en-US" sz="1500" dirty="0"/>
           </a:p>
@@ -6156,7 +7185,7 @@
                 <a:ea typeface="Calibri" pitchFamily="34" charset="-122"/>
                 <a:cs typeface="Calibri" pitchFamily="34" charset="-120"/>
               </a:rPr>
-              <a:t>Configure once per project; agents inherit them</a:t>
+              <a:t>Agent playground — test a Prompt agent or Hosted agent you've created in Foundry</a:t>
             </a:r>
             <a:endParaRPr lang="en-US" sz="1500" dirty="0"/>
           </a:p>
@@ -6177,7 +7206,7 @@
                 <a:ea typeface="Calibri" pitchFamily="34" charset="-122"/>
                 <a:cs typeface="Calibri" pitchFamily="34" charset="-120"/>
               </a:rPr>
-              <a:t>Auth via managed identity or service principal — never long-lived keys in production</a:t>
+              <a:t>Prompt flow / evaluation playgrounds — for testing eval configurations</a:t>
             </a:r>
             <a:endParaRPr lang="en-US" sz="1500" dirty="0"/>
           </a:p>
@@ -6198,7 +7227,28 @@
                 <a:ea typeface="Calibri" pitchFamily="34" charset="-122"/>
                 <a:cs typeface="Calibri" pitchFamily="34" charset="-120"/>
               </a:rPr>
-              <a:t>We wire connections for Foundry IQ knowledge sources on Day 2</a:t>
+              <a:t>Use playgrounds to sanity-check before writing agent code</a:t>
+            </a:r>
+            <a:endParaRPr lang="en-US" sz="1500" dirty="0"/>
+          </a:p>
+          <a:p>
+            <a:pPr marL="342900" indent="-342900">
+              <a:spcAft>
+                <a:spcPts val="600"/>
+              </a:spcAft>
+              <a:buSzPct val="100000"/>
+              <a:buChar char="•"/>
+            </a:pPr>
+            <a:r>
+              <a:rPr lang="en-US" sz="1500" dirty="0">
+                <a:solidFill>
+                  <a:srgbClr val="212121"/>
+                </a:solidFill>
+                <a:latin typeface="Calibri" pitchFamily="34" charset="0"/>
+                <a:ea typeface="Calibri" pitchFamily="34" charset="-122"/>
+                <a:cs typeface="Calibri" pitchFamily="34" charset="-120"/>
+              </a:rPr>
+              <a:t>If it doesn't work in the playground, it won't work in MAF either</a:t>
             </a:r>
             <a:endParaRPr lang="en-US" sz="1500" dirty="0"/>
           </a:p>
@@ -6218,7 +7268,7 @@
     <p:bg>
       <p:bgPr>
         <a:solidFill>
-          <a:srgbClr val="1E2761"/>
+          <a:srgbClr val="FFFFFF"/>
         </a:solidFill>
       </p:bgPr>
     </p:bg>
@@ -6238,14 +7288,34 @@
       </p:grpSpPr>
       <p:sp>
         <p:nvSpPr>
-          <p:cNvPr id="2" name="Text 0"/>
-          <p:cNvSpPr/>
-          <p:nvPr/>
-        </p:nvSpPr>
-        <p:spPr>
-          <a:xfrm>
-            <a:off x="548640" y="2011680"/>
-            <a:ext cx="8046720" cy="1097280"/>
+          <p:cNvPr id="2" name="Shape 0"/>
+          <p:cNvSpPr/>
+          <p:nvPr/>
+        </p:nvSpPr>
+        <p:spPr>
+          <a:xfrm>
+            <a:off x="0" y="0"/>
+            <a:ext cx="54864" cy="5143500"/>
+          </a:xfrm>
+          <a:prstGeom prst="rect">
+            <a:avLst/>
+          </a:prstGeom>
+          <a:solidFill>
+            <a:srgbClr val="1E2761"/>
+          </a:solidFill>
+          <a:ln/>
+        </p:spPr>
+      </p:sp>
+      <p:sp>
+        <p:nvSpPr>
+          <p:cNvPr id="3" name="Text 1"/>
+          <p:cNvSpPr/>
+          <p:nvPr/>
+        </p:nvSpPr>
+        <p:spPr>
+          <a:xfrm>
+            <a:off x="5669280" y="274320"/>
+            <a:ext cx="3291840" cy="274320"/>
           </a:xfrm>
           <a:prstGeom prst="rect">
             <a:avLst/>
@@ -6254,37 +7324,76 @@
           <a:ln/>
         </p:spPr>
         <p:txBody>
-          <a:bodyPr wrap="square" rtlCol="0" anchor="ctr"/>
+          <a:bodyPr wrap="square" lIns="0" tIns="0" rIns="0" bIns="0" rtlCol="0" anchor="ctr"/>
+          <a:lstStyle/>
+          <a:p>
+            <a:pPr algn="r" indent="0" marL="0">
+              <a:buNone/>
+            </a:pPr>
+            <a:r>
+              <a:rPr lang="en-US" sz="1000" dirty="0">
+                <a:solidFill>
+                  <a:srgbClr val="6B7280"/>
+                </a:solidFill>
+                <a:latin typeface="Calibri" pitchFamily="34" charset="0"/>
+                <a:ea typeface="Calibri" pitchFamily="34" charset="-122"/>
+                <a:cs typeface="Calibri" pitchFamily="34" charset="-120"/>
+              </a:rPr>
+              <a:t>Day 1 · Module 2</a:t>
+            </a:r>
+            <a:endParaRPr lang="en-US" sz="1000" dirty="0"/>
+          </a:p>
+        </p:txBody>
+      </p:sp>
+      <p:sp>
+        <p:nvSpPr>
+          <p:cNvPr id="4" name="Text 2"/>
+          <p:cNvSpPr/>
+          <p:nvPr/>
+        </p:nvSpPr>
+        <p:spPr>
+          <a:xfrm>
+            <a:off x="365760" y="320040"/>
+            <a:ext cx="6217920" cy="640080"/>
+          </a:xfrm>
+          <a:prstGeom prst="rect">
+            <a:avLst/>
+          </a:prstGeom>
+          <a:noFill/>
+          <a:ln/>
+        </p:spPr>
+        <p:txBody>
+          <a:bodyPr wrap="square" lIns="0" tIns="0" rIns="0" bIns="0" rtlCol="0" anchor="ctr"/>
           <a:lstStyle/>
           <a:p>
             <a:pPr indent="0" marL="0">
               <a:buNone/>
             </a:pPr>
             <a:r>
-              <a:rPr lang="en-US" sz="4000" b="1" dirty="0">
-                <a:solidFill>
-                  <a:srgbClr val="FFFFFF"/>
-                </a:solidFill>
-                <a:latin typeface="Calibri" pitchFamily="34" charset="0"/>
-                <a:ea typeface="Calibri" pitchFamily="34" charset="-122"/>
-                <a:cs typeface="Calibri" pitchFamily="34" charset="-120"/>
-              </a:rPr>
-              <a:t>Toolbox and Foundry IQ</a:t>
-            </a:r>
-            <a:endParaRPr lang="en-US" sz="4000" dirty="0"/>
-          </a:p>
-        </p:txBody>
-      </p:sp>
-      <p:sp>
-        <p:nvSpPr>
-          <p:cNvPr id="3" name="Text 1"/>
-          <p:cNvSpPr/>
-          <p:nvPr/>
-        </p:nvSpPr>
-        <p:spPr>
-          <a:xfrm>
-            <a:off x="548640" y="3108960"/>
-            <a:ext cx="8046720" cy="548640"/>
+              <a:rPr lang="en-US" sz="2800" b="1" dirty="0">
+                <a:solidFill>
+                  <a:srgbClr val="1E2761"/>
+                </a:solidFill>
+                <a:latin typeface="Calibri" pitchFamily="34" charset="0"/>
+                <a:ea typeface="Calibri" pitchFamily="34" charset="-122"/>
+                <a:cs typeface="Calibri" pitchFamily="34" charset="-120"/>
+              </a:rPr>
+              <a:t>Connections</a:t>
+            </a:r>
+            <a:endParaRPr lang="en-US" sz="2800" dirty="0"/>
+          </a:p>
+        </p:txBody>
+      </p:sp>
+      <p:sp>
+        <p:nvSpPr>
+          <p:cNvPr id="5" name="Text 3"/>
+          <p:cNvSpPr/>
+          <p:nvPr/>
+        </p:nvSpPr>
+        <p:spPr>
+          <a:xfrm>
+            <a:off x="365760" y="1097280"/>
+            <a:ext cx="8412480" cy="3749040"/>
           </a:xfrm>
           <a:prstGeom prst="rect">
             <a:avLst/>
@@ -6296,21 +7405,109 @@
           <a:bodyPr wrap="square" rtlCol="0" anchor="ctr"/>
           <a:lstStyle/>
           <a:p>
-            <a:pPr indent="0" marL="0">
-              <a:buNone/>
-            </a:pPr>
-            <a:r>
-              <a:rPr lang="en-US" sz="1800" dirty="0">
-                <a:solidFill>
-                  <a:srgbClr val="CADCFC"/>
-                </a:solidFill>
-                <a:latin typeface="Calibri" pitchFamily="34" charset="0"/>
-                <a:ea typeface="Calibri" pitchFamily="34" charset="-122"/>
-                <a:cs typeface="Calibri" pitchFamily="34" charset="-120"/>
-              </a:rPr>
-              <a:t>Introductions only — Days 2–3 go deep</a:t>
-            </a:r>
-            <a:endParaRPr lang="en-US" sz="1800" dirty="0"/>
+            <a:pPr marL="342900" indent="-342900">
+              <a:spcAft>
+                <a:spcPts val="600"/>
+              </a:spcAft>
+              <a:buSzPct val="100000"/>
+              <a:buChar char="•"/>
+            </a:pPr>
+            <a:r>
+              <a:rPr lang="en-US" sz="1500" dirty="0">
+                <a:solidFill>
+                  <a:srgbClr val="212121"/>
+                </a:solidFill>
+                <a:latin typeface="Calibri" pitchFamily="34" charset="0"/>
+                <a:ea typeface="Calibri" pitchFamily="34" charset="-122"/>
+                <a:cs typeface="Calibri" pitchFamily="34" charset="-120"/>
+              </a:rPr>
+              <a:t>How a Foundry resource references other Azure services — AI Search, Storage, Key Vault, Fabric, and more</a:t>
+            </a:r>
+            <a:endParaRPr lang="en-US" sz="1500" dirty="0"/>
+          </a:p>
+          <a:p>
+            <a:pPr marL="342900" indent="-342900">
+              <a:spcAft>
+                <a:spcPts val="600"/>
+              </a:spcAft>
+              <a:buSzPct val="100000"/>
+              <a:buChar char="•"/>
+            </a:pPr>
+            <a:r>
+              <a:rPr lang="en-US" sz="1500" dirty="0">
+                <a:solidFill>
+                  <a:srgbClr val="212121"/>
+                </a:solidFill>
+                <a:latin typeface="Calibri" pitchFamily="34" charset="0"/>
+                <a:ea typeface="Calibri" pitchFamily="34" charset="-122"/>
+                <a:cs typeface="Calibri" pitchFamily="34" charset="-120"/>
+              </a:rPr>
+              <a:t>Each connected resource is a separate Azure resource with its own networking and access policies</a:t>
+            </a:r>
+            <a:endParaRPr lang="en-US" sz="1500" dirty="0"/>
+          </a:p>
+          <a:p>
+            <a:pPr marL="342900" indent="-342900">
+              <a:spcAft>
+                <a:spcPts val="600"/>
+              </a:spcAft>
+              <a:buSzPct val="100000"/>
+              <a:buChar char="•"/>
+            </a:pPr>
+            <a:r>
+              <a:rPr lang="en-US" sz="1500" dirty="0">
+                <a:solidFill>
+                  <a:srgbClr val="212121"/>
+                </a:solidFill>
+                <a:latin typeface="Calibri" pitchFamily="34" charset="0"/>
+                <a:ea typeface="Calibri" pitchFamily="34" charset="-122"/>
+                <a:cs typeface="Calibri" pitchFamily="34" charset="-120"/>
+              </a:rPr>
+              <a:t>Configured on the Foundry resource; projects inherit them</a:t>
+            </a:r>
+            <a:endParaRPr lang="en-US" sz="1500" dirty="0"/>
+          </a:p>
+          <a:p>
+            <a:pPr marL="342900" indent="-342900">
+              <a:spcAft>
+                <a:spcPts val="600"/>
+              </a:spcAft>
+              <a:buSzPct val="100000"/>
+              <a:buChar char="•"/>
+            </a:pPr>
+            <a:r>
+              <a:rPr lang="en-US" sz="1500" dirty="0">
+                <a:solidFill>
+                  <a:srgbClr val="212121"/>
+                </a:solidFill>
+                <a:latin typeface="Calibri" pitchFamily="34" charset="0"/>
+                <a:ea typeface="Calibri" pitchFamily="34" charset="-122"/>
+                <a:cs typeface="Calibri" pitchFamily="34" charset="-120"/>
+              </a:rPr>
+              <a:t>Auth via managed identity or service principal — never long-lived keys in production</a:t>
+            </a:r>
+            <a:endParaRPr lang="en-US" sz="1500" dirty="0"/>
+          </a:p>
+          <a:p>
+            <a:pPr marL="342900" indent="-342900">
+              <a:spcAft>
+                <a:spcPts val="600"/>
+              </a:spcAft>
+              <a:buSzPct val="100000"/>
+              <a:buChar char="•"/>
+            </a:pPr>
+            <a:r>
+              <a:rPr lang="en-US" sz="1500" dirty="0">
+                <a:solidFill>
+                  <a:srgbClr val="212121"/>
+                </a:solidFill>
+                <a:latin typeface="Calibri" pitchFamily="34" charset="0"/>
+                <a:ea typeface="Calibri" pitchFamily="34" charset="-122"/>
+                <a:cs typeface="Calibri" pitchFamily="34" charset="-120"/>
+              </a:rPr>
+              <a:t>We wire connections for Foundry IQ knowledge sources on Day 2</a:t>
+            </a:r>
+            <a:endParaRPr lang="en-US" sz="1500" dirty="0"/>
           </a:p>
         </p:txBody>
       </p:sp>

</xml_diff>

<commit_message>
Day 1 Module 2: use canonical Foundry architecture diagram from Learn
Replaced the hand-rolled boxes-and-pills architecture slide with the
canonical SVG diagram from
learn.microsoft.com/en-us/azure/foundry/concepts/architecture, cached
in-repo under slides/day1/assets/ (SVG source + rasterized PNG for
PowerPoint compatibility).

- On-slide attribution caption added
- altText populated for accessibility
- Rasterized via @resvg/resvg-js at 1800px wide
- slides/day1/README.md documents the assets directory
- plan.md updated with diagram-sourcing policy: source from authoritative
  Microsoft docs and MAF/Foundry repos, cache in slides/dayN/assets/,
  attribute on-slide, prefer PNG

Co-authored-by: Copilot <223556219+Copilot@users.noreply.github.com>
</commit_message>
<xml_diff>
--- a/decks/day1/module-2-foundry-portal.pptx
+++ b/decks/day1/module-2-foundry-portal.pptx
@@ -1309,7 +1309,7 @@
           <a:p>
             <a:r>
               <a:rPr lang="en-US" dirty="0"/>
-              <a:t>This is the mental map for Foundry governance. Emphasize that connected resources (Storage, Key Vault, AI Search) are independent Azure resources — you manage their networking and access separately. The Foundry resource references them through connections.</a:t>
+              <a:t>Diagram from Microsoft Learn (foundry/concepts/architecture). Walk the four layers explicitly: (1) Foundry resource is the governance boundary — deployments, security, connections. (2) Projects are development boundaries nested inside. (3) Project assets are files, agents, evaluations. (4) Connected resources (Storage, Key Vault, AI Search) are separate Azure resources with their own governance — you manage networking and access for them independently.</a:t>
             </a:r>
             <a:endParaRPr lang="en-US" dirty="0"/>
           </a:p>
@@ -4976,41 +4976,40 @@
           </a:p>
         </p:txBody>
       </p:sp>
-      <p:sp>
-        <p:nvSpPr>
-          <p:cNvPr id="5" name="Shape 3"/>
-          <p:cNvSpPr/>
-          <p:nvPr/>
-        </p:nvSpPr>
-        <p:spPr>
-          <a:xfrm>
-            <a:off x="365760" y="1051560"/>
-            <a:ext cx="5120640" cy="3108960"/>
-          </a:xfrm>
-          <a:prstGeom prst="rect">
-            <a:avLst/>
-          </a:prstGeom>
-          <a:solidFill>
-            <a:srgbClr val="FFFFFF"/>
-          </a:solidFill>
-          <a:ln w="25400">
-            <a:solidFill>
-              <a:srgbClr val="1E2761"/>
-            </a:solidFill>
-            <a:prstDash val="solid"/>
-          </a:ln>
-        </p:spPr>
-      </p:sp>
-      <p:sp>
-        <p:nvSpPr>
-          <p:cNvPr id="6" name="Text 4"/>
-          <p:cNvSpPr/>
-          <p:nvPr/>
-        </p:nvSpPr>
-        <p:spPr>
-          <a:xfrm>
-            <a:off x="457200" y="1124712"/>
-            <a:ext cx="4937760" cy="320040"/>
+      <p:pic>
+        <p:nvPicPr>
+          <p:cNvPr id="5" name="Image 0" descr="[object Object]">    </p:cNvPr>
+          <p:cNvPicPr>
+            <a:picLocks noChangeAspect="1"/>
+          </p:cNvPicPr>
+          <p:nvPr/>
+        </p:nvPicPr>
+        <p:blipFill>
+          <a:blip r:embed="rId1"/>
+          <a:stretch>
+            <a:fillRect/>
+          </a:stretch>
+        </p:blipFill>
+        <p:spPr>
+          <a:xfrm>
+            <a:off x="2013575" y="1097280"/>
+            <a:ext cx="5116850" cy="3291840"/>
+          </a:xfrm>
+          <a:prstGeom prst="rect">
+            <a:avLst/>
+          </a:prstGeom>
+        </p:spPr>
+      </p:pic>
+      <p:sp>
+        <p:nvSpPr>
+          <p:cNvPr id="6" name="Text 3"/>
+          <p:cNvSpPr/>
+          <p:nvPr/>
+        </p:nvSpPr>
+        <p:spPr>
+          <a:xfrm>
+            <a:off x="365760" y="4434840"/>
+            <a:ext cx="8412480" cy="228600"/>
           </a:xfrm>
           <a:prstGeom prst="rect">
             <a:avLst/>
@@ -5022,39 +5021,37 @@
           <a:bodyPr wrap="square" lIns="0" tIns="0" rIns="0" bIns="0" rtlCol="0" anchor="ctr"/>
           <a:lstStyle/>
           <a:p>
-            <a:pPr indent="0" marL="0">
+            <a:pPr algn="ctr" indent="0" marL="0">
               <a:buNone/>
             </a:pPr>
             <a:r>
-              <a:rPr lang="en-US" sz="1300" b="1" dirty="0">
-                <a:solidFill>
-                  <a:srgbClr val="1E2761"/>
-                </a:solidFill>
-                <a:latin typeface="Calibri" pitchFamily="34" charset="0"/>
-                <a:ea typeface="Calibri" pitchFamily="34" charset="-122"/>
-                <a:cs typeface="Calibri" pitchFamily="34" charset="-120"/>
-              </a:rPr>
-              <a:t>Foundry resource · governance boundary</a:t>
-            </a:r>
-            <a:endParaRPr lang="en-US" sz="1300" dirty="0"/>
-          </a:p>
-        </p:txBody>
-      </p:sp>
-      <p:sp>
-        <p:nvSpPr>
-          <p:cNvPr id="7" name="Shape 5"/>
-          <p:cNvSpPr/>
-          <p:nvPr/>
-        </p:nvSpPr>
-        <p:spPr>
-          <a:xfrm>
-            <a:off x="502920" y="1554480"/>
-            <a:ext cx="1554480" cy="365760"/>
-          </a:xfrm>
-          <a:prstGeom prst="roundRect">
-            <a:avLst>
-              <a:gd name="adj" fmla="val 20000"/>
-            </a:avLst>
+              <a:rPr lang="en-US" sz="900" i="1" dirty="0">
+                <a:solidFill>
+                  <a:srgbClr val="6B7280"/>
+                </a:solidFill>
+                <a:latin typeface="Calibri" pitchFamily="34" charset="0"/>
+                <a:ea typeface="Calibri" pitchFamily="34" charset="-122"/>
+                <a:cs typeface="Calibri" pitchFamily="34" charset="-120"/>
+              </a:rPr>
+              <a:t>Diagram: Microsoft Learn · aka.ms/foundry/architecture</a:t>
+            </a:r>
+            <a:endParaRPr lang="en-US" sz="900" dirty="0"/>
+          </a:p>
+        </p:txBody>
+      </p:sp>
+      <p:sp>
+        <p:nvSpPr>
+          <p:cNvPr id="7" name="Shape 4"/>
+          <p:cNvSpPr/>
+          <p:nvPr/>
+        </p:nvSpPr>
+        <p:spPr>
+          <a:xfrm>
+            <a:off x="365760" y="4617720"/>
+            <a:ext cx="8412480" cy="457200"/>
+          </a:xfrm>
+          <a:prstGeom prst="rect">
+            <a:avLst/>
           </a:prstGeom>
           <a:solidFill>
             <a:srgbClr val="CADCFC"/>
@@ -5064,568 +5061,14 @@
       </p:sp>
       <p:sp>
         <p:nvSpPr>
-          <p:cNvPr id="8" name="Text 6"/>
-          <p:cNvSpPr/>
-          <p:nvPr/>
-        </p:nvSpPr>
-        <p:spPr>
-          <a:xfrm>
-            <a:off x="502920" y="1554480"/>
-            <a:ext cx="1554480" cy="365760"/>
-          </a:xfrm>
-          <a:prstGeom prst="rect">
-            <a:avLst/>
-          </a:prstGeom>
-          <a:noFill/>
-          <a:ln/>
-        </p:spPr>
-        <p:txBody>
-          <a:bodyPr wrap="square" lIns="0" tIns="0" rIns="0" bIns="0" rtlCol="0" anchor="ctr"/>
-          <a:lstStyle/>
-          <a:p>
-            <a:pPr algn="ctr" indent="0" marL="0">
-              <a:buNone/>
-            </a:pPr>
-            <a:r>
-              <a:rPr lang="en-US" sz="1000" b="1" dirty="0">
-                <a:solidFill>
-                  <a:srgbClr val="1E2761"/>
-                </a:solidFill>
-                <a:latin typeface="Calibri" pitchFamily="34" charset="0"/>
-                <a:ea typeface="Calibri" pitchFamily="34" charset="-122"/>
-                <a:cs typeface="Calibri" pitchFamily="34" charset="-120"/>
-              </a:rPr>
-              <a:t>Model deployments</a:t>
-            </a:r>
-            <a:endParaRPr lang="en-US" sz="1000" dirty="0"/>
-          </a:p>
-        </p:txBody>
-      </p:sp>
-      <p:sp>
-        <p:nvSpPr>
-          <p:cNvPr id="9" name="Shape 7"/>
-          <p:cNvSpPr/>
-          <p:nvPr/>
-        </p:nvSpPr>
-        <p:spPr>
-          <a:xfrm>
-            <a:off x="2148840" y="1554480"/>
-            <a:ext cx="1554480" cy="365760"/>
-          </a:xfrm>
-          <a:prstGeom prst="roundRect">
-            <a:avLst>
-              <a:gd name="adj" fmla="val 20000"/>
-            </a:avLst>
-          </a:prstGeom>
-          <a:solidFill>
-            <a:srgbClr val="CADCFC"/>
-          </a:solidFill>
-          <a:ln/>
-        </p:spPr>
-      </p:sp>
-      <p:sp>
-        <p:nvSpPr>
-          <p:cNvPr id="10" name="Text 8"/>
-          <p:cNvSpPr/>
-          <p:nvPr/>
-        </p:nvSpPr>
-        <p:spPr>
-          <a:xfrm>
-            <a:off x="2148840" y="1554480"/>
-            <a:ext cx="1554480" cy="365760"/>
-          </a:xfrm>
-          <a:prstGeom prst="rect">
-            <a:avLst/>
-          </a:prstGeom>
-          <a:noFill/>
-          <a:ln/>
-        </p:spPr>
-        <p:txBody>
-          <a:bodyPr wrap="square" lIns="0" tIns="0" rIns="0" bIns="0" rtlCol="0" anchor="ctr"/>
-          <a:lstStyle/>
-          <a:p>
-            <a:pPr algn="ctr" indent="0" marL="0">
-              <a:buNone/>
-            </a:pPr>
-            <a:r>
-              <a:rPr lang="en-US" sz="1000" b="1" dirty="0">
-                <a:solidFill>
-                  <a:srgbClr val="1E2761"/>
-                </a:solidFill>
-                <a:latin typeface="Calibri" pitchFamily="34" charset="0"/>
-                <a:ea typeface="Calibri" pitchFamily="34" charset="-122"/>
-                <a:cs typeface="Calibri" pitchFamily="34" charset="-120"/>
-              </a:rPr>
-              <a:t>Security &amp; networking</a:t>
-            </a:r>
-            <a:endParaRPr lang="en-US" sz="1000" dirty="0"/>
-          </a:p>
-        </p:txBody>
-      </p:sp>
-      <p:sp>
-        <p:nvSpPr>
-          <p:cNvPr id="11" name="Shape 9"/>
-          <p:cNvSpPr/>
-          <p:nvPr/>
-        </p:nvSpPr>
-        <p:spPr>
-          <a:xfrm>
-            <a:off x="3794760" y="1554480"/>
-            <a:ext cx="1554480" cy="365760"/>
-          </a:xfrm>
-          <a:prstGeom prst="roundRect">
-            <a:avLst>
-              <a:gd name="adj" fmla="val 20000"/>
-            </a:avLst>
-          </a:prstGeom>
-          <a:solidFill>
-            <a:srgbClr val="CADCFC"/>
-          </a:solidFill>
-          <a:ln/>
-        </p:spPr>
-      </p:sp>
-      <p:sp>
-        <p:nvSpPr>
-          <p:cNvPr id="12" name="Text 10"/>
-          <p:cNvSpPr/>
-          <p:nvPr/>
-        </p:nvSpPr>
-        <p:spPr>
-          <a:xfrm>
-            <a:off x="3794760" y="1554480"/>
-            <a:ext cx="1554480" cy="365760"/>
-          </a:xfrm>
-          <a:prstGeom prst="rect">
-            <a:avLst/>
-          </a:prstGeom>
-          <a:noFill/>
-          <a:ln/>
-        </p:spPr>
-        <p:txBody>
-          <a:bodyPr wrap="square" lIns="0" tIns="0" rIns="0" bIns="0" rtlCol="0" anchor="ctr"/>
-          <a:lstStyle/>
-          <a:p>
-            <a:pPr algn="ctr" indent="0" marL="0">
-              <a:buNone/>
-            </a:pPr>
-            <a:r>
-              <a:rPr lang="en-US" sz="1000" b="1" dirty="0">
-                <a:solidFill>
-                  <a:srgbClr val="1E2761"/>
-                </a:solidFill>
-                <a:latin typeface="Calibri" pitchFamily="34" charset="0"/>
-                <a:ea typeface="Calibri" pitchFamily="34" charset="-122"/>
-                <a:cs typeface="Calibri" pitchFamily="34" charset="-120"/>
-              </a:rPr>
-              <a:t>Connections</a:t>
-            </a:r>
-            <a:endParaRPr lang="en-US" sz="1000" dirty="0"/>
-          </a:p>
-        </p:txBody>
-      </p:sp>
-      <p:sp>
-        <p:nvSpPr>
-          <p:cNvPr id="13" name="Shape 11"/>
-          <p:cNvSpPr/>
-          <p:nvPr/>
-        </p:nvSpPr>
-        <p:spPr>
-          <a:xfrm>
-            <a:off x="502920" y="2103120"/>
-            <a:ext cx="4846320" cy="1920240"/>
-          </a:xfrm>
-          <a:prstGeom prst="rect">
-            <a:avLst/>
-          </a:prstGeom>
-          <a:solidFill>
-            <a:srgbClr val="F3F4F6"/>
-          </a:solidFill>
-          <a:ln w="12700">
-            <a:solidFill>
-              <a:srgbClr val="1E2761"/>
-            </a:solidFill>
-            <a:prstDash val="dash"/>
-          </a:ln>
-        </p:spPr>
-      </p:sp>
-      <p:sp>
-        <p:nvSpPr>
-          <p:cNvPr id="14" name="Text 12"/>
-          <p:cNvSpPr/>
-          <p:nvPr/>
-        </p:nvSpPr>
-        <p:spPr>
-          <a:xfrm>
-            <a:off x="594360" y="2176272"/>
-            <a:ext cx="4663440" cy="292608"/>
-          </a:xfrm>
-          <a:prstGeom prst="rect">
-            <a:avLst/>
-          </a:prstGeom>
-          <a:noFill/>
-          <a:ln/>
-        </p:spPr>
-        <p:txBody>
-          <a:bodyPr wrap="square" lIns="0" tIns="0" rIns="0" bIns="0" rtlCol="0" anchor="ctr"/>
-          <a:lstStyle/>
-          <a:p>
-            <a:pPr indent="0" marL="0">
-              <a:buNone/>
-            </a:pPr>
-            <a:r>
-              <a:rPr lang="en-US" sz="1200" b="1" dirty="0">
-                <a:solidFill>
-                  <a:srgbClr val="1E2761"/>
-                </a:solidFill>
-                <a:latin typeface="Calibri" pitchFamily="34" charset="0"/>
-                <a:ea typeface="Calibri" pitchFamily="34" charset="-122"/>
-                <a:cs typeface="Calibri" pitchFamily="34" charset="-120"/>
-              </a:rPr>
-              <a:t>Project · development boundary</a:t>
-            </a:r>
-            <a:endParaRPr lang="en-US" sz="1200" dirty="0"/>
-          </a:p>
-        </p:txBody>
-      </p:sp>
-      <p:sp>
-        <p:nvSpPr>
-          <p:cNvPr id="15" name="Text 13"/>
-          <p:cNvSpPr/>
-          <p:nvPr/>
-        </p:nvSpPr>
-        <p:spPr>
-          <a:xfrm>
-            <a:off x="594360" y="2560320"/>
-            <a:ext cx="4663440" cy="457200"/>
-          </a:xfrm>
-          <a:prstGeom prst="rect">
-            <a:avLst/>
-          </a:prstGeom>
-          <a:noFill/>
-          <a:ln/>
-        </p:spPr>
-        <p:txBody>
-          <a:bodyPr wrap="square" lIns="0" tIns="0" rIns="0" bIns="0" rtlCol="0" anchor="ctr"/>
-          <a:lstStyle/>
-          <a:p>
-            <a:pPr indent="0" marL="0">
-              <a:buNone/>
-            </a:pPr>
-            <a:r>
-              <a:rPr lang="en-US" sz="1100" i="1" dirty="0">
-                <a:solidFill>
-                  <a:srgbClr val="212121"/>
-                </a:solidFill>
-                <a:latin typeface="Calibri" pitchFamily="34" charset="0"/>
-                <a:ea typeface="Calibri" pitchFamily="34" charset="-122"/>
-                <a:cs typeface="Calibri" pitchFamily="34" charset="-120"/>
-              </a:rPr>
-              <a:t>Project assets: files · agents · evaluations</a:t>
-            </a:r>
-            <a:endParaRPr lang="en-US" sz="1100" dirty="0"/>
-          </a:p>
-        </p:txBody>
-      </p:sp>
-      <p:sp>
-        <p:nvSpPr>
-          <p:cNvPr id="16" name="Text 14"/>
-          <p:cNvSpPr/>
-          <p:nvPr/>
-        </p:nvSpPr>
-        <p:spPr>
-          <a:xfrm>
-            <a:off x="5852160" y="1124712"/>
-            <a:ext cx="2926080" cy="274320"/>
-          </a:xfrm>
-          <a:prstGeom prst="rect">
-            <a:avLst/>
-          </a:prstGeom>
-          <a:noFill/>
-          <a:ln/>
-        </p:spPr>
-        <p:txBody>
-          <a:bodyPr wrap="square" lIns="0" tIns="0" rIns="0" bIns="0" rtlCol="0" anchor="ctr"/>
-          <a:lstStyle/>
-          <a:p>
-            <a:pPr indent="0" marL="0">
-              <a:buNone/>
-            </a:pPr>
-            <a:r>
-              <a:rPr lang="en-US" sz="1300" b="1" dirty="0">
-                <a:solidFill>
-                  <a:srgbClr val="1E2761"/>
-                </a:solidFill>
-                <a:latin typeface="Calibri" pitchFamily="34" charset="0"/>
-                <a:ea typeface="Calibri" pitchFamily="34" charset="-122"/>
-                <a:cs typeface="Calibri" pitchFamily="34" charset="-120"/>
-              </a:rPr>
-              <a:t>Connected resources</a:t>
-            </a:r>
-            <a:endParaRPr lang="en-US" sz="1300" dirty="0"/>
-          </a:p>
-        </p:txBody>
-      </p:sp>
-      <p:sp>
-        <p:nvSpPr>
-          <p:cNvPr id="17" name="Text 15"/>
-          <p:cNvSpPr/>
-          <p:nvPr/>
-        </p:nvSpPr>
-        <p:spPr>
-          <a:xfrm>
-            <a:off x="5852160" y="1417320"/>
-            <a:ext cx="2926080" cy="274320"/>
-          </a:xfrm>
-          <a:prstGeom prst="rect">
-            <a:avLst/>
-          </a:prstGeom>
-          <a:noFill/>
-          <a:ln/>
-        </p:spPr>
-        <p:txBody>
-          <a:bodyPr wrap="square" lIns="0" tIns="0" rIns="0" bIns="0" rtlCol="0" anchor="ctr"/>
-          <a:lstStyle/>
-          <a:p>
-            <a:pPr indent="0" marL="0">
-              <a:buNone/>
-            </a:pPr>
-            <a:r>
-              <a:rPr lang="en-US" sz="1000" i="1" dirty="0">
-                <a:solidFill>
-                  <a:srgbClr val="6B7280"/>
-                </a:solidFill>
-                <a:latin typeface="Calibri" pitchFamily="34" charset="0"/>
-                <a:ea typeface="Calibri" pitchFamily="34" charset="-122"/>
-                <a:cs typeface="Calibri" pitchFamily="34" charset="-120"/>
-              </a:rPr>
-              <a:t>separate Azure resources · own governance</a:t>
-            </a:r>
-            <a:endParaRPr lang="en-US" sz="1000" dirty="0"/>
-          </a:p>
-        </p:txBody>
-      </p:sp>
-      <p:sp>
-        <p:nvSpPr>
-          <p:cNvPr id="18" name="Shape 16"/>
-          <p:cNvSpPr/>
-          <p:nvPr/>
-        </p:nvSpPr>
-        <p:spPr>
-          <a:xfrm>
-            <a:off x="5852160" y="1828800"/>
-            <a:ext cx="2926080" cy="640080"/>
-          </a:xfrm>
-          <a:prstGeom prst="rect">
-            <a:avLst/>
-          </a:prstGeom>
-          <a:solidFill>
-            <a:srgbClr val="FFFFFF"/>
-          </a:solidFill>
-          <a:ln w="12700">
-            <a:solidFill>
-              <a:srgbClr val="D1D5DB"/>
-            </a:solidFill>
-            <a:prstDash val="dash"/>
-          </a:ln>
-        </p:spPr>
-      </p:sp>
-      <p:sp>
-        <p:nvSpPr>
-          <p:cNvPr id="19" name="Text 17"/>
-          <p:cNvSpPr/>
-          <p:nvPr/>
-        </p:nvSpPr>
-        <p:spPr>
-          <a:xfrm>
-            <a:off x="5852160" y="1828800"/>
-            <a:ext cx="2926080" cy="640080"/>
-          </a:xfrm>
-          <a:prstGeom prst="rect">
-            <a:avLst/>
-          </a:prstGeom>
-          <a:noFill/>
-          <a:ln/>
-        </p:spPr>
-        <p:txBody>
-          <a:bodyPr wrap="square" lIns="0" tIns="0" rIns="0" bIns="0" rtlCol="0" anchor="ctr"/>
-          <a:lstStyle/>
-          <a:p>
-            <a:pPr algn="ctr" indent="0" marL="0">
-              <a:buNone/>
-            </a:pPr>
-            <a:r>
-              <a:rPr lang="en-US" sz="1200" b="1" dirty="0">
-                <a:solidFill>
-                  <a:srgbClr val="212121"/>
-                </a:solidFill>
-                <a:latin typeface="Calibri" pitchFamily="34" charset="0"/>
-                <a:ea typeface="Calibri" pitchFamily="34" charset="-122"/>
-                <a:cs typeface="Calibri" pitchFamily="34" charset="-120"/>
-              </a:rPr>
-              <a:t>Azure Storage</a:t>
-            </a:r>
-            <a:endParaRPr lang="en-US" sz="1200" dirty="0"/>
-          </a:p>
-        </p:txBody>
-      </p:sp>
-      <p:sp>
-        <p:nvSpPr>
-          <p:cNvPr id="20" name="Shape 18"/>
-          <p:cNvSpPr/>
-          <p:nvPr/>
-        </p:nvSpPr>
-        <p:spPr>
-          <a:xfrm>
-            <a:off x="5852160" y="2606040"/>
-            <a:ext cx="2926080" cy="640080"/>
-          </a:xfrm>
-          <a:prstGeom prst="rect">
-            <a:avLst/>
-          </a:prstGeom>
-          <a:solidFill>
-            <a:srgbClr val="FFFFFF"/>
-          </a:solidFill>
-          <a:ln w="12700">
-            <a:solidFill>
-              <a:srgbClr val="D1D5DB"/>
-            </a:solidFill>
-            <a:prstDash val="dash"/>
-          </a:ln>
-        </p:spPr>
-      </p:sp>
-      <p:sp>
-        <p:nvSpPr>
-          <p:cNvPr id="21" name="Text 19"/>
-          <p:cNvSpPr/>
-          <p:nvPr/>
-        </p:nvSpPr>
-        <p:spPr>
-          <a:xfrm>
-            <a:off x="5852160" y="2606040"/>
-            <a:ext cx="2926080" cy="640080"/>
-          </a:xfrm>
-          <a:prstGeom prst="rect">
-            <a:avLst/>
-          </a:prstGeom>
-          <a:noFill/>
-          <a:ln/>
-        </p:spPr>
-        <p:txBody>
-          <a:bodyPr wrap="square" lIns="0" tIns="0" rIns="0" bIns="0" rtlCol="0" anchor="ctr"/>
-          <a:lstStyle/>
-          <a:p>
-            <a:pPr algn="ctr" indent="0" marL="0">
-              <a:buNone/>
-            </a:pPr>
-            <a:r>
-              <a:rPr lang="en-US" sz="1200" b="1" dirty="0">
-                <a:solidFill>
-                  <a:srgbClr val="212121"/>
-                </a:solidFill>
-                <a:latin typeface="Calibri" pitchFamily="34" charset="0"/>
-                <a:ea typeface="Calibri" pitchFamily="34" charset="-122"/>
-                <a:cs typeface="Calibri" pitchFamily="34" charset="-120"/>
-              </a:rPr>
-              <a:t>Azure Key Vault</a:t>
-            </a:r>
-            <a:endParaRPr lang="en-US" sz="1200" dirty="0"/>
-          </a:p>
-        </p:txBody>
-      </p:sp>
-      <p:sp>
-        <p:nvSpPr>
-          <p:cNvPr id="22" name="Shape 20"/>
-          <p:cNvSpPr/>
-          <p:nvPr/>
-        </p:nvSpPr>
-        <p:spPr>
-          <a:xfrm>
-            <a:off x="5852160" y="3383280"/>
-            <a:ext cx="2926080" cy="640080"/>
-          </a:xfrm>
-          <a:prstGeom prst="rect">
-            <a:avLst/>
-          </a:prstGeom>
-          <a:solidFill>
-            <a:srgbClr val="FFFFFF"/>
-          </a:solidFill>
-          <a:ln w="12700">
-            <a:solidFill>
-              <a:srgbClr val="D1D5DB"/>
-            </a:solidFill>
-            <a:prstDash val="dash"/>
-          </a:ln>
-        </p:spPr>
-      </p:sp>
-      <p:sp>
-        <p:nvSpPr>
-          <p:cNvPr id="23" name="Text 21"/>
-          <p:cNvSpPr/>
-          <p:nvPr/>
-        </p:nvSpPr>
-        <p:spPr>
-          <a:xfrm>
-            <a:off x="5852160" y="3383280"/>
-            <a:ext cx="2926080" cy="640080"/>
-          </a:xfrm>
-          <a:prstGeom prst="rect">
-            <a:avLst/>
-          </a:prstGeom>
-          <a:noFill/>
-          <a:ln/>
-        </p:spPr>
-        <p:txBody>
-          <a:bodyPr wrap="square" lIns="0" tIns="0" rIns="0" bIns="0" rtlCol="0" anchor="ctr"/>
-          <a:lstStyle/>
-          <a:p>
-            <a:pPr algn="ctr" indent="0" marL="0">
-              <a:buNone/>
-            </a:pPr>
-            <a:r>
-              <a:rPr lang="en-US" sz="1200" b="1" dirty="0">
-                <a:solidFill>
-                  <a:srgbClr val="212121"/>
-                </a:solidFill>
-                <a:latin typeface="Calibri" pitchFamily="34" charset="0"/>
-                <a:ea typeface="Calibri" pitchFamily="34" charset="-122"/>
-                <a:cs typeface="Calibri" pitchFamily="34" charset="-120"/>
-              </a:rPr>
-              <a:t>Azure AI Search</a:t>
-            </a:r>
-            <a:endParaRPr lang="en-US" sz="1200" dirty="0"/>
-          </a:p>
-        </p:txBody>
-      </p:sp>
-      <p:sp>
-        <p:nvSpPr>
-          <p:cNvPr id="24" name="Shape 22"/>
-          <p:cNvSpPr/>
-          <p:nvPr/>
-        </p:nvSpPr>
-        <p:spPr>
-          <a:xfrm>
-            <a:off x="365760" y="4297680"/>
-            <a:ext cx="8412480" cy="502920"/>
-          </a:xfrm>
-          <a:prstGeom prst="rect">
-            <a:avLst/>
-          </a:prstGeom>
-          <a:solidFill>
-            <a:srgbClr val="CADCFC"/>
-          </a:solidFill>
-          <a:ln/>
-        </p:spPr>
-      </p:sp>
-      <p:sp>
-        <p:nvSpPr>
-          <p:cNvPr id="25" name="Text 23"/>
-          <p:cNvSpPr/>
-          <p:nvPr/>
-        </p:nvSpPr>
-        <p:spPr>
-          <a:xfrm>
-            <a:off x="502920" y="4343400"/>
-            <a:ext cx="8138160" cy="411480"/>
+          <p:cNvPr id="8" name="Text 5"/>
+          <p:cNvSpPr/>
+          <p:nvPr/>
+        </p:nvSpPr>
+        <p:spPr>
+          <a:xfrm>
+            <a:off x="502920" y="4645152"/>
+            <a:ext cx="8138160" cy="402336"/>
           </a:xfrm>
           <a:prstGeom prst="rect">
             <a:avLst/>

</xml_diff>

<commit_message>
Rewrite on-slide audience references from 3rd to 1st person
The audience was being referred to as 'attendees' on slides ('Standard
workflow attendees will use', 'Attendees learned eval on Day 2 Module 3',
etc.). Rewrote all on-slide occurrences to address the reader directly
('you' / 'you'll' / 'try it yourself').

Speaker notes are left third-person on purpose — those are the private
direction the presenter reads in Presenter View.

Sweep covered:
  slides/day1/*.md — 3 files, 3 rewrites
  slides/day2/*.md — 6 files, 10 rewrites
  scripts/build-decks/day1.js — 3 on-slide rewrites
  scripts/build-decks/day2.js — 6 on-slide rewrites

Verified with an XML text scan across all 15 generated .pptx slide files:
0 remaining on-slide 'attendee' references. Speaker notes untouched.

All 15 decks regenerated and valid.

Co-authored-by: Copilot <223556219+Copilot@users.noreply.github.com>
</commit_message>
<xml_diff>
--- a/decks/day1/module-2-foundry-portal.pptx
+++ b/decks/day1/module-2-foundry-portal.pptx
@@ -4966,7 +4966,7 @@
                 <a:ea typeface="Calibri" pitchFamily="34" charset="-122"/>
                 <a:cs typeface="Calibri" pitchFamily="34" charset="-120"/>
               </a:rPr>
-              <a:t>Missing role assignments — attendees need at least Foundry User (previously Azure AI User) at the Foundry resource scope; 401/403 usually means this</a:t>
+              <a:t>Missing role assignments — you need at least Foundry User (previously Azure AI User) at the Foundry resource scope; 401/403 usually means this</a:t>
             </a:r>
             <a:endParaRPr lang="en-US" sz="1500" dirty="0"/>
           </a:p>
@@ -5325,7 +5325,7 @@
                 <a:ea typeface="Calibri" pitchFamily="34" charset="-122"/>
                 <a:cs typeface="Calibri" pitchFamily="34" charset="-120"/>
               </a:rPr>
-              <a:t>Attendees: do steps 1–4 on your own sub before the module ends.</a:t>
+              <a:t>Try it yourself: do steps 1–4 on your own sub before the module ends.</a:t>
             </a:r>
             <a:endParaRPr lang="en-US" sz="1400" dirty="0"/>
           </a:p>

</xml_diff>